<commit_message>
ejercicios LO.1-LO.7 + pptx
</commit_message>
<xml_diff>
--- a/LabBook_30.pptx
+++ b/LabBook_30.pptx
@@ -242,7 +242,7 @@
           <a:p>
             <a:fld id="{8438F8DC-35B0-48E6-A86E-42F1F08DD00F}" type="datetimeFigureOut">
               <a:rPr lang="es-ES" smtClean="0"/>
-              <a:t>23/05/2026</a:t>
+              <a:t>25/05/2026</a:t>
             </a:fld>
             <a:endParaRPr lang="es-ES"/>
           </a:p>
@@ -419,7 +419,7 @@
           <a:p>
             <a:fld id="{FACBDC12-F39B-4B97-8F4D-6734F9D366FF}" type="datetimeFigureOut">
               <a:rPr lang="es-ES" smtClean="0"/>
-              <a:t>23/05/2026</a:t>
+              <a:t>25/05/2026</a:t>
             </a:fld>
             <a:endParaRPr lang="es-ES"/>
           </a:p>
@@ -2982,18 +2982,25 @@
               </a:spcBef>
             </a:pPr>
             <a:r>
-              <a:rPr lang="es-ES" spc="165" dirty="0" err="1">
+              <a:rPr lang="es-ES" b="1" i="1" spc="165" dirty="0" err="1">
                 <a:latin typeface="Arial"/>
                 <a:cs typeface="Arial"/>
               </a:rPr>
               <a:t>Students</a:t>
             </a:r>
             <a:r>
+              <a:rPr lang="es-ES" b="1" i="1" spc="165" dirty="0">
+                <a:latin typeface="Arial"/>
+                <a:cs typeface="Arial"/>
+              </a:rPr>
+              <a:t>:</a:t>
+            </a:r>
+            <a:r>
               <a:rPr lang="es-ES" spc="165" dirty="0">
                 <a:latin typeface="Arial"/>
                 <a:cs typeface="Arial"/>
               </a:rPr>
-              <a:t>: Lidia Tórtola Juan y Raúl Salido Calatayud</a:t>
+              <a:t> Lidia Tórtola Juan y Raúl Salido Calatayud</a:t>
             </a:r>
             <a:endParaRPr sz="1800" dirty="0">
               <a:latin typeface="Arial"/>
@@ -3057,6 +3064,51 @@
               <a:t>1</a:t>
             </a:fld>
             <a:endParaRPr lang="es-ES"/>
+          </a:p>
+        </p:txBody>
+      </p:sp>
+      <p:sp>
+        <p:nvSpPr>
+          <p:cNvPr id="2" name="CuadroTexto 1">
+            <a:extLst>
+              <a:ext uri="{FF2B5EF4-FFF2-40B4-BE49-F238E27FC236}">
+                <a16:creationId xmlns:a16="http://schemas.microsoft.com/office/drawing/2014/main" id="{97380A6D-AE0C-0F93-A308-6EF9EB603605}"/>
+              </a:ext>
+            </a:extLst>
+          </p:cNvPr>
+          <p:cNvSpPr txBox="1"/>
+          <p:nvPr/>
+        </p:nvSpPr>
+        <p:spPr>
+          <a:xfrm>
+            <a:off x="2663890" y="5892089"/>
+            <a:ext cx="8305800" cy="369332"/>
+          </a:xfrm>
+          <a:prstGeom prst="rect">
+            <a:avLst/>
+          </a:prstGeom>
+          <a:noFill/>
+        </p:spPr>
+        <p:txBody>
+          <a:bodyPr wrap="square">
+            <a:spAutoFit/>
+          </a:bodyPr>
+          <a:lstStyle/>
+          <a:p>
+            <a:r>
+              <a:rPr lang="es-ES" b="1" i="1" dirty="0">
+                <a:latin typeface="Arial" panose="020B0604020202020204" pitchFamily="34" charset="0"/>
+                <a:cs typeface="Arial" panose="020B0604020202020204" pitchFamily="34" charset="0"/>
+              </a:rPr>
+              <a:t>URL:</a:t>
+            </a:r>
+            <a:r>
+              <a:rPr lang="es-ES" dirty="0">
+                <a:latin typeface="Arial" panose="020B0604020202020204" pitchFamily="34" charset="0"/>
+                <a:cs typeface="Arial" panose="020B0604020202020204" pitchFamily="34" charset="0"/>
+              </a:rPr>
+              <a:t> https://github.com/ltorjua/cifoin-lab3</a:t>
+            </a:r>
           </a:p>
         </p:txBody>
       </p:sp>
@@ -3255,8 +3307,8 @@
           </a:p>
         </p:txBody>
       </p:sp>
-      <mc:AlternateContent xmlns:mc="http://schemas.openxmlformats.org/markup-compatibility/2006">
-        <mc:Choice xmlns:a14="http://schemas.microsoft.com/office/drawing/2010/main" Requires="a14">
+      <mc:AlternateContent xmlns:mc="http://schemas.openxmlformats.org/markup-compatibility/2006" xmlns:a14="http://schemas.microsoft.com/office/drawing/2010/main">
+        <mc:Choice Requires="a14">
           <p:sp>
             <p:nvSpPr>
               <p:cNvPr id="2" name="CuadroTexto 1">
@@ -3348,14 +3400,18 @@
                     <m:d>
                       <m:dPr>
                         <m:ctrlPr>
-                          <a:rPr lang="ar-AE" sz="1200"/>
+                          <a:rPr lang="ar-AE" sz="1200" i="1">
+                            <a:latin typeface="Cambria Math" panose="02040503050406030204" pitchFamily="18" charset="0"/>
+                          </a:rPr>
                         </m:ctrlPr>
                       </m:dPr>
                       <m:e>
                         <m:sSub>
                           <m:sSubPr>
                             <m:ctrlPr>
-                              <a:rPr lang="ar-AE" sz="1200"/>
+                              <a:rPr lang="ar-AE" sz="1200" i="1">
+                                <a:latin typeface="Cambria Math" panose="02040503050406030204" pitchFamily="18" charset="0"/>
+                              </a:rPr>
                             </m:ctrlPr>
                           </m:sSubPr>
                           <m:e>
@@ -3390,7 +3446,9 @@
                         <m:sSub>
                           <m:sSubPr>
                             <m:ctrlPr>
-                              <a:rPr lang="ar-AE" sz="1200"/>
+                              <a:rPr lang="ar-AE" sz="1200" i="1">
+                                <a:latin typeface="Cambria Math" panose="02040503050406030204" pitchFamily="18" charset="0"/>
+                              </a:rPr>
                             </m:ctrlPr>
                           </m:sSubPr>
                           <m:e>
@@ -3526,14 +3584,18 @@
                       <m:dPr>
                         <m:sepChr m:val=","/>
                         <m:ctrlPr>
-                          <a:rPr lang="ar-AE" sz="1200"/>
+                          <a:rPr lang="ar-AE" sz="1200" i="1">
+                            <a:latin typeface="Cambria Math" panose="02040503050406030204" pitchFamily="18" charset="0"/>
+                          </a:rPr>
                         </m:ctrlPr>
                       </m:dPr>
                       <m:e>
                         <m:sSub>
                           <m:sSubPr>
                             <m:ctrlPr>
-                              <a:rPr lang="ar-AE" sz="1200"/>
+                              <a:rPr lang="ar-AE" sz="1200" i="1">
+                                <a:latin typeface="Cambria Math" panose="02040503050406030204" pitchFamily="18" charset="0"/>
+                              </a:rPr>
                             </m:ctrlPr>
                           </m:sSubPr>
                           <m:e>
@@ -3598,7 +3660,9 @@
                         <m:sSub>
                           <m:sSubPr>
                             <m:ctrlPr>
-                              <a:rPr lang="ar-AE" sz="1200"/>
+                              <a:rPr lang="ar-AE" sz="1200" i="1">
+                                <a:latin typeface="Cambria Math" panose="02040503050406030204" pitchFamily="18" charset="0"/>
+                              </a:rPr>
                             </m:ctrlPr>
                           </m:sSubPr>
                           <m:e>
@@ -3670,7 +3734,9 @@
                     <m:sSub>
                       <m:sSubPr>
                         <m:ctrlPr>
-                          <a:rPr lang="ar-AE" sz="1200"/>
+                          <a:rPr lang="ar-AE" sz="1200" i="1">
+                            <a:latin typeface="Cambria Math" panose="02040503050406030204" pitchFamily="18" charset="0"/>
+                          </a:rPr>
                         </m:ctrlPr>
                       </m:sSubPr>
                       <m:e>
@@ -3810,7 +3876,7 @@
             </p:txBody>
           </p:sp>
         </mc:Choice>
-        <mc:Fallback>
+        <mc:Fallback xmlns="">
           <p:sp>
             <p:nvSpPr>
               <p:cNvPr id="2" name="CuadroTexto 1">
@@ -4477,8 +4543,8 @@
           </a:p>
         </p:txBody>
       </p:sp>
-      <mc:AlternateContent xmlns:mc="http://schemas.openxmlformats.org/markup-compatibility/2006">
-        <mc:Choice xmlns:a14="http://schemas.microsoft.com/office/drawing/2010/main" Requires="a14">
+      <mc:AlternateContent xmlns:mc="http://schemas.openxmlformats.org/markup-compatibility/2006" xmlns:a14="http://schemas.microsoft.com/office/drawing/2010/main">
+        <mc:Choice Requires="a14">
           <p:sp>
             <p:nvSpPr>
               <p:cNvPr id="8" name="CuadroTexto 7">
@@ -4765,7 +4831,7 @@
             </p:txBody>
           </p:sp>
         </mc:Choice>
-        <mc:Fallback>
+        <mc:Fallback xmlns="">
           <p:sp>
             <p:nvSpPr>
               <p:cNvPr id="8" name="CuadroTexto 7">
@@ -5681,8 +5747,8 @@
           </a:p>
         </p:txBody>
       </p:sp>
-      <mc:AlternateContent xmlns:mc="http://schemas.openxmlformats.org/markup-compatibility/2006">
-        <mc:Choice xmlns:a14="http://schemas.microsoft.com/office/drawing/2010/main" Requires="a14">
+      <mc:AlternateContent xmlns:mc="http://schemas.openxmlformats.org/markup-compatibility/2006" xmlns:a14="http://schemas.microsoft.com/office/drawing/2010/main">
+        <mc:Choice Requires="a14">
           <p:sp>
             <p:nvSpPr>
               <p:cNvPr id="8" name="CuadroTexto 7">
@@ -5757,7 +5823,9 @@
                     <m:sSub>
                       <m:sSubPr>
                         <m:ctrlPr>
-                          <a:rPr lang="ar-AE" sz="1200"/>
+                          <a:rPr lang="ar-AE" sz="1200" i="1">
+                            <a:latin typeface="Cambria Math" panose="02040503050406030204" pitchFamily="18" charset="0"/>
+                          </a:rPr>
                         </m:ctrlPr>
                       </m:sSubPr>
                       <m:e>
@@ -5765,7 +5833,9 @@
                           <m:rPr>
                             <m:sty m:val="p"/>
                           </m:rPr>
-                          <a:rPr lang="ar-AE" sz="1200" b="0" i="0"/>
+                          <a:rPr lang="ar-AE" sz="1200" b="0" i="0">
+                            <a:latin typeface="Cambria Math" panose="02040503050406030204" pitchFamily="18" charset="0"/>
+                          </a:rPr>
                           <m:t>L</m:t>
                         </m:r>
                       </m:e>
@@ -5774,25 +5844,35 @@
                           <m:rPr>
                             <m:sty m:val="p"/>
                           </m:rPr>
-                          <a:rPr lang="ar-AE" sz="1200" b="0" i="0"/>
+                          <a:rPr lang="ar-AE" sz="1200" b="0" i="0">
+                            <a:latin typeface="Cambria Math" panose="02040503050406030204" pitchFamily="18" charset="0"/>
+                          </a:rPr>
                           <m:t>r</m:t>
                         </m:r>
                       </m:sub>
                     </m:sSub>
                     <m:r>
-                      <a:rPr lang="ar-AE" sz="1200" b="0" i="0"/>
+                      <a:rPr lang="ar-AE" sz="1200" b="0" i="0">
+                        <a:latin typeface="Cambria Math" panose="02040503050406030204" pitchFamily="18" charset="0"/>
+                      </a:rPr>
                       <m:t>≈</m:t>
                     </m:r>
                     <m:r>
-                      <a:rPr lang="ar-AE" sz="1200" b="0" i="0"/>
+                      <a:rPr lang="ar-AE" sz="1200" b="0" i="0">
+                        <a:latin typeface="Cambria Math" panose="02040503050406030204" pitchFamily="18" charset="0"/>
+                      </a:rPr>
                       <m:t>80</m:t>
                     </m:r>
                     <m:r>
-                      <a:rPr lang="ar-AE" sz="1200" b="0" i="0"/>
+                      <a:rPr lang="ar-AE" sz="1200" b="0" i="0">
+                        <a:latin typeface="Cambria Math" panose="02040503050406030204" pitchFamily="18" charset="0"/>
+                      </a:rPr>
                       <m:t>.</m:t>
                     </m:r>
                     <m:r>
-                      <a:rPr lang="ar-AE" sz="1200" b="0" i="0"/>
+                      <a:rPr lang="ar-AE" sz="1200" b="0" i="0">
+                        <a:latin typeface="Cambria Math" panose="02040503050406030204" pitchFamily="18" charset="0"/>
+                      </a:rPr>
                       <m:t>08</m:t>
                     </m:r>
                     <m:r>
@@ -5809,7 +5889,9 @@
                       <m:rPr>
                         <m:sty m:val="p"/>
                       </m:rPr>
-                      <a:rPr lang="ar-AE" sz="1200" b="0" i="0"/>
+                      <a:rPr lang="ar-AE" sz="1200" b="0" i="0">
+                        <a:latin typeface="Cambria Math" panose="02040503050406030204" pitchFamily="18" charset="0"/>
+                      </a:rPr>
                       <m:t>μm</m:t>
                     </m:r>
                   </m:oMath>
@@ -5868,28 +5950,38 @@
                         <m:rPr>
                           <m:sty m:val="p"/>
                         </m:rPr>
-                        <a:rPr lang="es-ES" sz="1200" b="0" i="0"/>
+                        <a:rPr lang="es-ES" sz="1200" b="0" i="0">
+                          <a:latin typeface="Cambria Math" panose="02040503050406030204" pitchFamily="18" charset="0"/>
+                        </a:rPr>
                         <m:t>ER</m:t>
                       </m:r>
                       <m:r>
-                        <a:rPr lang="es-ES" sz="1200" b="0" i="0"/>
+                        <a:rPr lang="es-ES" sz="1200" b="0" i="0">
+                          <a:latin typeface="Cambria Math" panose="02040503050406030204" pitchFamily="18" charset="0"/>
+                        </a:rPr>
                         <m:t>≈</m:t>
                       </m:r>
                       <m:r>
-                        <a:rPr lang="es-ES" sz="1200" b="0" i="0"/>
+                        <a:rPr lang="es-ES" sz="1200" b="0" i="0">
+                          <a:latin typeface="Cambria Math" panose="02040503050406030204" pitchFamily="18" charset="0"/>
+                        </a:rPr>
                         <m:t>10</m:t>
                       </m:r>
                       <m:sSub>
                         <m:sSubPr>
                           <m:ctrlPr>
-                            <a:rPr lang="ar-AE" sz="1200"/>
+                            <a:rPr lang="ar-AE" sz="1200" i="1">
+                              <a:latin typeface="Cambria Math" panose="02040503050406030204" pitchFamily="18" charset="0"/>
+                            </a:rPr>
                           </m:ctrlPr>
                         </m:sSubPr>
                         <m:e>
                           <m:func>
                             <m:funcPr>
                               <m:ctrlPr>
-                                <a:rPr lang="ar-AE" sz="1200"/>
+                                <a:rPr lang="ar-AE" sz="1200" i="1">
+                                  <a:latin typeface="Cambria Math" panose="02040503050406030204" pitchFamily="18" charset="0"/>
+                                </a:rPr>
                               </m:ctrlPr>
                             </m:funcPr>
                             <m:fName>
@@ -5897,7 +5989,9 @@
                                 <m:rPr>
                                   <m:sty m:val="p"/>
                                 </m:rPr>
-                                <a:rPr lang="es-ES" sz="1200" b="0" i="0"/>
+                                <a:rPr lang="es-ES" sz="1200" b="0" i="0">
+                                  <a:latin typeface="Cambria Math" panose="02040503050406030204" pitchFamily="18" charset="0"/>
+                                </a:rPr>
                                 <m:t>log</m:t>
                               </m:r>
                             </m:fName>
@@ -5913,7 +6007,9 @@
                         </m:e>
                         <m:sub>
                           <m:r>
-                            <a:rPr lang="ar-AE" sz="1200" b="0" i="0"/>
+                            <a:rPr lang="ar-AE" sz="1200" b="0" i="0">
+                              <a:latin typeface="Cambria Math" panose="02040503050406030204" pitchFamily="18" charset="0"/>
+                            </a:rPr>
                             <m:t>10</m:t>
                           </m:r>
                         </m:sub>
@@ -5921,14 +6017,18 @@
                       <m:d>
                         <m:dPr>
                           <m:ctrlPr>
-                            <a:rPr lang="ar-AE" sz="1200"/>
+                            <a:rPr lang="ar-AE" sz="1200" i="1">
+                              <a:latin typeface="Cambria Math" panose="02040503050406030204" pitchFamily="18" charset="0"/>
+                            </a:rPr>
                           </m:ctrlPr>
                         </m:dPr>
                         <m:e>
                           <m:f>
                             <m:fPr>
                               <m:ctrlPr>
-                                <a:rPr lang="ar-AE" sz="1200"/>
+                                <a:rPr lang="ar-AE" sz="1200" i="1">
+                                  <a:latin typeface="Cambria Math" panose="02040503050406030204" pitchFamily="18" charset="0"/>
+                                </a:rPr>
                               </m:ctrlPr>
                             </m:fPr>
                             <m:num>
@@ -6001,7 +6101,7 @@
                       <m:sSub>
                         <m:sSubPr>
                           <m:ctrlPr>
-                            <a:rPr lang="ar-AE" sz="1200">
+                            <a:rPr lang="ar-AE" sz="1200" i="1">
                               <a:latin typeface="Cambria Math" panose="02040503050406030204" pitchFamily="18" charset="0"/>
                             </a:rPr>
                           </m:ctrlPr>
@@ -6010,7 +6110,7 @@
                           <m:func>
                             <m:funcPr>
                               <m:ctrlPr>
-                                <a:rPr lang="ar-AE" sz="1200">
+                                <a:rPr lang="ar-AE" sz="1200" i="1">
                                   <a:latin typeface="Cambria Math" panose="02040503050406030204" pitchFamily="18" charset="0"/>
                                 </a:rPr>
                               </m:ctrlPr>
@@ -6048,7 +6148,7 @@
                       <m:d>
                         <m:dPr>
                           <m:ctrlPr>
-                            <a:rPr lang="ar-AE" sz="1200">
+                            <a:rPr lang="ar-AE" sz="1200" i="1">
                               <a:latin typeface="Cambria Math" panose="02040503050406030204" pitchFamily="18" charset="0"/>
                             </a:rPr>
                           </m:ctrlPr>
@@ -6057,7 +6157,7 @@
                           <m:f>
                             <m:fPr>
                               <m:ctrlPr>
-                                <a:rPr lang="ar-AE" sz="1200">
+                                <a:rPr lang="ar-AE" sz="1200" i="1">
                                   <a:latin typeface="Cambria Math" panose="02040503050406030204" pitchFamily="18" charset="0"/>
                                 </a:rPr>
                               </m:ctrlPr>
@@ -6094,11 +6194,15 @@
                         </m:e>
                       </m:d>
                       <m:r>
-                        <a:rPr lang="ar-AE" sz="1200" b="0" i="0"/>
+                        <a:rPr lang="ar-AE" sz="1200" b="0" i="0">
+                          <a:latin typeface="Cambria Math" panose="02040503050406030204" pitchFamily="18" charset="0"/>
+                        </a:rPr>
                         <m:t>≈</m:t>
                       </m:r>
                       <m:r>
-                        <a:rPr lang="ar-AE" sz="1200" b="0" i="0"/>
+                        <a:rPr lang="ar-AE" sz="1200" b="0" i="0">
+                          <a:latin typeface="Cambria Math" panose="02040503050406030204" pitchFamily="18" charset="0"/>
+                        </a:rPr>
                         <m:t>10</m:t>
                       </m:r>
                       <m:r>
@@ -6115,7 +6219,9 @@
                         <m:rPr>
                           <m:sty m:val="p"/>
                         </m:rPr>
-                        <a:rPr lang="ar-AE" sz="1200" b="0" i="0"/>
+                        <a:rPr lang="ar-AE" sz="1200" b="0" i="0">
+                          <a:latin typeface="Cambria Math" panose="02040503050406030204" pitchFamily="18" charset="0"/>
+                        </a:rPr>
                         <m:t>dB</m:t>
                       </m:r>
                     </m:oMath>
@@ -6188,7 +6294,7 @@
             </p:txBody>
           </p:sp>
         </mc:Choice>
-        <mc:Fallback>
+        <mc:Fallback xmlns="">
           <p:sp>
             <p:nvSpPr>
               <p:cNvPr id="8" name="CuadroTexto 7">
@@ -6430,72 +6536,10 @@
       </p:sp>
       <p:sp>
         <p:nvSpPr>
-          <p:cNvPr id="8" name="CuadroTexto 7">
+          <p:cNvPr id="14" name="Rectángulo 13">
             <a:extLst>
               <a:ext uri="{FF2B5EF4-FFF2-40B4-BE49-F238E27FC236}">
-                <a16:creationId xmlns:a16="http://schemas.microsoft.com/office/drawing/2014/main" id="{D9601617-351E-AE1A-1F4D-693F2EA59361}"/>
-              </a:ext>
-            </a:extLst>
-          </p:cNvPr>
-          <p:cNvSpPr txBox="1"/>
-          <p:nvPr/>
-        </p:nvSpPr>
-        <p:spPr>
-          <a:xfrm>
-            <a:off x="611029" y="4860335"/>
-            <a:ext cx="11199530" cy="646331"/>
-          </a:xfrm>
-          <a:prstGeom prst="rect">
-            <a:avLst/>
-          </a:prstGeom>
-          <a:solidFill>
-            <a:schemeClr val="bg1">
-              <a:lumMod val="95000"/>
-            </a:schemeClr>
-          </a:solidFill>
-          <a:ln w="28575">
-            <a:solidFill>
-              <a:srgbClr val="E0700D"/>
-            </a:solidFill>
-          </a:ln>
-        </p:spPr>
-        <p:txBody>
-          <a:bodyPr wrap="square" rtlCol="0">
-            <a:spAutoFit/>
-          </a:bodyPr>
-          <a:lstStyle/>
-          <a:p>
-            <a:pPr algn="just"/>
-            <a:r>
-              <a:rPr lang="en-US" sz="1200" dirty="0">
-                <a:latin typeface="Arial" panose="020B0604020202020204" pitchFamily="34" charset="0"/>
-                <a:cs typeface="Arial" panose="020B0604020202020204" pitchFamily="34" charset="0"/>
-              </a:rPr>
-              <a:t>Comment results: Try to classify the resonances, in which case are you close to critical coupling? Why?</a:t>
-            </a:r>
-          </a:p>
-          <a:p>
-            <a:pPr algn="just"/>
-            <a:endParaRPr lang="en-US" sz="1200" dirty="0">
-              <a:latin typeface="Arial" panose="020B0604020202020204" pitchFamily="34" charset="0"/>
-              <a:cs typeface="Arial" panose="020B0604020202020204" pitchFamily="34" charset="0"/>
-            </a:endParaRPr>
-          </a:p>
-          <a:p>
-            <a:pPr algn="just"/>
-            <a:endParaRPr lang="en-US" sz="1200" dirty="0">
-              <a:latin typeface="Arial" panose="020B0604020202020204" pitchFamily="34" charset="0"/>
-              <a:cs typeface="Arial" panose="020B0604020202020204" pitchFamily="34" charset="0"/>
-            </a:endParaRPr>
-          </a:p>
-        </p:txBody>
-      </p:sp>
-      <p:sp>
-        <p:nvSpPr>
-          <p:cNvPr id="11" name="Rectángulo 10">
-            <a:extLst>
-              <a:ext uri="{FF2B5EF4-FFF2-40B4-BE49-F238E27FC236}">
-                <a16:creationId xmlns:a16="http://schemas.microsoft.com/office/drawing/2014/main" id="{B811A5F9-C0B5-716C-70FB-9472E1BC2CD3}"/>
+                <a16:creationId xmlns:a16="http://schemas.microsoft.com/office/drawing/2014/main" id="{6AA857E7-5C39-DCE1-10B5-40300FCF4B26}"/>
               </a:ext>
             </a:extLst>
           </p:cNvPr>
@@ -6504,8 +6548,8 @@
         </p:nvSpPr>
         <p:spPr>
           <a:xfrm>
-            <a:off x="611030" y="1418373"/>
-            <a:ext cx="2538552" cy="3306028"/>
+            <a:off x="685800" y="1419036"/>
+            <a:ext cx="5410200" cy="4114465"/>
           </a:xfrm>
           <a:prstGeom prst="rect">
             <a:avLst/>
@@ -6544,186 +6588,6 @@
       </p:sp>
       <p:sp>
         <p:nvSpPr>
-          <p:cNvPr id="14" name="Rectángulo 13">
-            <a:extLst>
-              <a:ext uri="{FF2B5EF4-FFF2-40B4-BE49-F238E27FC236}">
-                <a16:creationId xmlns:a16="http://schemas.microsoft.com/office/drawing/2014/main" id="{6AA857E7-5C39-DCE1-10B5-40300FCF4B26}"/>
-              </a:ext>
-            </a:extLst>
-          </p:cNvPr>
-          <p:cNvSpPr/>
-          <p:nvPr/>
-        </p:nvSpPr>
-        <p:spPr>
-          <a:xfrm>
-            <a:off x="3277315" y="1419036"/>
-            <a:ext cx="2538552" cy="3306028"/>
-          </a:xfrm>
-          <a:prstGeom prst="rect">
-            <a:avLst/>
-          </a:prstGeom>
-          <a:noFill/>
-          <a:ln w="28575">
-            <a:solidFill>
-              <a:srgbClr val="E0700D"/>
-            </a:solidFill>
-          </a:ln>
-        </p:spPr>
-        <p:style>
-          <a:lnRef idx="2">
-            <a:schemeClr val="accent1">
-              <a:shade val="15000"/>
-            </a:schemeClr>
-          </a:lnRef>
-          <a:fillRef idx="1">
-            <a:schemeClr val="accent1"/>
-          </a:fillRef>
-          <a:effectRef idx="0">
-            <a:schemeClr val="accent1"/>
-          </a:effectRef>
-          <a:fontRef idx="minor">
-            <a:schemeClr val="lt1"/>
-          </a:fontRef>
-        </p:style>
-        <p:txBody>
-          <a:bodyPr rtlCol="0" anchor="ctr"/>
-          <a:lstStyle/>
-          <a:p>
-            <a:pPr algn="ctr"/>
-            <a:endParaRPr lang="en-US"/>
-          </a:p>
-        </p:txBody>
-      </p:sp>
-      <p:sp>
-        <p:nvSpPr>
-          <p:cNvPr id="15" name="CuadroTexto 14">
-            <a:extLst>
-              <a:ext uri="{FF2B5EF4-FFF2-40B4-BE49-F238E27FC236}">
-                <a16:creationId xmlns:a16="http://schemas.microsoft.com/office/drawing/2014/main" id="{54CF28B4-1346-F41D-2CD8-EA104ABBFB98}"/>
-              </a:ext>
-            </a:extLst>
-          </p:cNvPr>
-          <p:cNvSpPr txBox="1"/>
-          <p:nvPr/>
-        </p:nvSpPr>
-        <p:spPr>
-          <a:xfrm>
-            <a:off x="863650" y="2101891"/>
-            <a:ext cx="2033313" cy="1938992"/>
-          </a:xfrm>
-          <a:prstGeom prst="rect">
-            <a:avLst/>
-          </a:prstGeom>
-          <a:noFill/>
-        </p:spPr>
-        <p:txBody>
-          <a:bodyPr wrap="none" rtlCol="0">
-            <a:spAutoFit/>
-          </a:bodyPr>
-          <a:lstStyle/>
-          <a:p>
-            <a:pPr algn="ctr"/>
-            <a:r>
-              <a:rPr lang="es-ES" sz="2000" dirty="0"/>
-              <a:t>Single ring</a:t>
-            </a:r>
-          </a:p>
-          <a:p>
-            <a:pPr algn="ctr"/>
-            <a:r>
-              <a:rPr lang="es-ES" sz="2000" dirty="0"/>
-              <a:t>transfer </a:t>
-            </a:r>
-            <a:r>
-              <a:rPr lang="es-ES" sz="2000" dirty="0" err="1"/>
-              <a:t>functions</a:t>
-            </a:r>
-            <a:endParaRPr lang="es-ES" sz="2000" dirty="0"/>
-          </a:p>
-          <a:p>
-            <a:pPr algn="ctr"/>
-            <a:endParaRPr lang="es-ES" sz="2000" dirty="0"/>
-          </a:p>
-          <a:p>
-            <a:pPr algn="ctr"/>
-            <a:r>
-              <a:rPr lang="es-ES" sz="2000" dirty="0"/>
-              <a:t>Linear </a:t>
-            </a:r>
-            <a:r>
-              <a:rPr lang="es-ES" sz="2000" dirty="0" err="1"/>
-              <a:t>units</a:t>
-            </a:r>
-            <a:endParaRPr lang="es-ES" sz="2000" dirty="0"/>
-          </a:p>
-          <a:p>
-            <a:pPr algn="ctr"/>
-            <a:endParaRPr lang="es-ES" sz="2000" dirty="0"/>
-          </a:p>
-          <a:p>
-            <a:pPr algn="ctr"/>
-            <a:r>
-              <a:rPr lang="es-ES" sz="2000" dirty="0"/>
-              <a:t>K=</a:t>
-            </a:r>
-            <a:endParaRPr lang="en-US" sz="2000" dirty="0"/>
-          </a:p>
-        </p:txBody>
-      </p:sp>
-      <p:sp>
-        <p:nvSpPr>
-          <p:cNvPr id="9" name="Rectángulo 8">
-            <a:extLst>
-              <a:ext uri="{FF2B5EF4-FFF2-40B4-BE49-F238E27FC236}">
-                <a16:creationId xmlns:a16="http://schemas.microsoft.com/office/drawing/2014/main" id="{11F0F5FC-B571-59FC-7890-3105A6A843BB}"/>
-              </a:ext>
-            </a:extLst>
-          </p:cNvPr>
-          <p:cNvSpPr/>
-          <p:nvPr/>
-        </p:nvSpPr>
-        <p:spPr>
-          <a:xfrm>
-            <a:off x="5943600" y="1418373"/>
-            <a:ext cx="2538552" cy="3306028"/>
-          </a:xfrm>
-          <a:prstGeom prst="rect">
-            <a:avLst/>
-          </a:prstGeom>
-          <a:noFill/>
-          <a:ln w="28575">
-            <a:solidFill>
-              <a:srgbClr val="E0700D"/>
-            </a:solidFill>
-          </a:ln>
-        </p:spPr>
-        <p:style>
-          <a:lnRef idx="2">
-            <a:schemeClr val="accent1">
-              <a:shade val="15000"/>
-            </a:schemeClr>
-          </a:lnRef>
-          <a:fillRef idx="1">
-            <a:schemeClr val="accent1"/>
-          </a:fillRef>
-          <a:effectRef idx="0">
-            <a:schemeClr val="accent1"/>
-          </a:effectRef>
-          <a:fontRef idx="minor">
-            <a:schemeClr val="lt1"/>
-          </a:fontRef>
-        </p:style>
-        <p:txBody>
-          <a:bodyPr rtlCol="0" anchor="ctr"/>
-          <a:lstStyle/>
-          <a:p>
-            <a:pPr algn="ctr"/>
-            <a:endParaRPr lang="en-US"/>
-          </a:p>
-        </p:txBody>
-      </p:sp>
-      <p:sp>
-        <p:nvSpPr>
           <p:cNvPr id="10" name="CuadroTexto 9">
             <a:extLst>
               <a:ext uri="{FF2B5EF4-FFF2-40B4-BE49-F238E27FC236}">
@@ -6793,119 +6657,6 @@
             <a:r>
               <a:rPr lang="es-ES" sz="2000" dirty="0"/>
               <a:t>K=</a:t>
-            </a:r>
-            <a:endParaRPr lang="en-US" sz="2000" dirty="0"/>
-          </a:p>
-        </p:txBody>
-      </p:sp>
-      <p:sp>
-        <p:nvSpPr>
-          <p:cNvPr id="13" name="CuadroTexto 12">
-            <a:extLst>
-              <a:ext uri="{FF2B5EF4-FFF2-40B4-BE49-F238E27FC236}">
-                <a16:creationId xmlns:a16="http://schemas.microsoft.com/office/drawing/2014/main" id="{057C499E-829F-FB11-9128-843C937CB822}"/>
-              </a:ext>
-            </a:extLst>
-          </p:cNvPr>
-          <p:cNvSpPr txBox="1"/>
-          <p:nvPr/>
-        </p:nvSpPr>
-        <p:spPr>
-          <a:xfrm>
-            <a:off x="6195187" y="2101891"/>
-            <a:ext cx="2033313" cy="1938992"/>
-          </a:xfrm>
-          <a:prstGeom prst="rect">
-            <a:avLst/>
-          </a:prstGeom>
-          <a:noFill/>
-        </p:spPr>
-        <p:txBody>
-          <a:bodyPr wrap="none" rtlCol="0">
-            <a:spAutoFit/>
-          </a:bodyPr>
-          <a:lstStyle/>
-          <a:p>
-            <a:pPr algn="ctr"/>
-            <a:r>
-              <a:rPr lang="es-ES" sz="2000" dirty="0"/>
-              <a:t>Single ring</a:t>
-            </a:r>
-          </a:p>
-          <a:p>
-            <a:pPr algn="ctr"/>
-            <a:r>
-              <a:rPr lang="es-ES" sz="2000" dirty="0"/>
-              <a:t>transfer </a:t>
-            </a:r>
-            <a:r>
-              <a:rPr lang="es-ES" sz="2000" dirty="0" err="1"/>
-              <a:t>functions</a:t>
-            </a:r>
-            <a:endParaRPr lang="es-ES" sz="2000" dirty="0"/>
-          </a:p>
-          <a:p>
-            <a:pPr algn="ctr"/>
-            <a:endParaRPr lang="es-ES" sz="2000" dirty="0"/>
-          </a:p>
-          <a:p>
-            <a:pPr algn="ctr"/>
-            <a:r>
-              <a:rPr lang="es-ES" sz="2000" dirty="0"/>
-              <a:t>Linear </a:t>
-            </a:r>
-            <a:r>
-              <a:rPr lang="es-ES" sz="2000" dirty="0" err="1"/>
-              <a:t>units</a:t>
-            </a:r>
-            <a:endParaRPr lang="es-ES" sz="2000" dirty="0"/>
-          </a:p>
-          <a:p>
-            <a:pPr algn="ctr"/>
-            <a:endParaRPr lang="es-ES" sz="2000" dirty="0"/>
-          </a:p>
-          <a:p>
-            <a:pPr algn="ctr"/>
-            <a:r>
-              <a:rPr lang="es-ES" sz="2000" dirty="0"/>
-              <a:t>K=</a:t>
-            </a:r>
-            <a:endParaRPr lang="en-US" sz="2000" dirty="0"/>
-          </a:p>
-        </p:txBody>
-      </p:sp>
-      <p:sp>
-        <p:nvSpPr>
-          <p:cNvPr id="12" name="CuadroTexto 11">
-            <a:extLst>
-              <a:ext uri="{FF2B5EF4-FFF2-40B4-BE49-F238E27FC236}">
-                <a16:creationId xmlns:a16="http://schemas.microsoft.com/office/drawing/2014/main" id="{4E78CC89-1377-28A4-024D-1B017D551FC5}"/>
-              </a:ext>
-            </a:extLst>
-          </p:cNvPr>
-          <p:cNvSpPr txBox="1"/>
-          <p:nvPr/>
-        </p:nvSpPr>
-        <p:spPr>
-          <a:xfrm>
-            <a:off x="9869875" y="2871332"/>
-            <a:ext cx="360996" cy="400110"/>
-          </a:xfrm>
-          <a:prstGeom prst="rect">
-            <a:avLst/>
-          </a:prstGeom>
-          <a:noFill/>
-        </p:spPr>
-        <p:txBody>
-          <a:bodyPr wrap="none" rtlCol="0">
-            <a:spAutoFit/>
-          </a:bodyPr>
-          <a:lstStyle/>
-          <a:p>
-            <a:pPr algn="ctr"/>
-            <a:r>
-              <a:rPr lang="es-ES" sz="2000" dirty="0"/>
-              <a:t>…</a:t>
             </a:r>
             <a:endParaRPr lang="en-US" sz="2000" dirty="0"/>
           </a:p>
@@ -7013,6 +6764,650 @@
           </a:p>
         </p:txBody>
       </p:sp>
+      <p:pic>
+        <p:nvPicPr>
+          <p:cNvPr id="4" name="Imagen 3">
+            <a:extLst>
+              <a:ext uri="{FF2B5EF4-FFF2-40B4-BE49-F238E27FC236}">
+                <a16:creationId xmlns:a16="http://schemas.microsoft.com/office/drawing/2014/main" id="{90C7E63C-F870-18CE-FE43-2DC9321515D5}"/>
+              </a:ext>
+            </a:extLst>
+          </p:cNvPr>
+          <p:cNvPicPr>
+            <a:picLocks noChangeAspect="1"/>
+          </p:cNvPicPr>
+          <p:nvPr/>
+        </p:nvPicPr>
+        <p:blipFill>
+          <a:blip r:embed="rId3"/>
+          <a:stretch>
+            <a:fillRect/>
+          </a:stretch>
+        </p:blipFill>
+        <p:spPr>
+          <a:xfrm>
+            <a:off x="833859" y="1541527"/>
+            <a:ext cx="5237259" cy="3790529"/>
+          </a:xfrm>
+          <a:prstGeom prst="rect">
+            <a:avLst/>
+          </a:prstGeom>
+        </p:spPr>
+      </p:pic>
+      <mc:AlternateContent xmlns:mc="http://schemas.openxmlformats.org/markup-compatibility/2006">
+        <mc:Choice xmlns:a14="http://schemas.microsoft.com/office/drawing/2010/main" Requires="a14">
+          <p:sp>
+            <p:nvSpPr>
+              <p:cNvPr id="7" name="CuadroTexto 6">
+                <a:extLst>
+                  <a:ext uri="{FF2B5EF4-FFF2-40B4-BE49-F238E27FC236}">
+                    <a16:creationId xmlns:a16="http://schemas.microsoft.com/office/drawing/2014/main" id="{3B4E8CED-CB99-A17B-0D7A-6C4D30ADE644}"/>
+                  </a:ext>
+                </a:extLst>
+              </p:cNvPr>
+              <p:cNvSpPr txBox="1"/>
+              <p:nvPr/>
+            </p:nvSpPr>
+            <p:spPr>
+              <a:xfrm>
+                <a:off x="6553200" y="1419036"/>
+                <a:ext cx="5127010" cy="4339650"/>
+              </a:xfrm>
+              <a:prstGeom prst="rect">
+                <a:avLst/>
+              </a:prstGeom>
+              <a:solidFill>
+                <a:schemeClr val="bg1">
+                  <a:lumMod val="95000"/>
+                </a:schemeClr>
+              </a:solidFill>
+              <a:ln w="28575">
+                <a:solidFill>
+                  <a:srgbClr val="E0700D"/>
+                </a:solidFill>
+              </a:ln>
+            </p:spPr>
+            <p:txBody>
+              <a:bodyPr wrap="square" rtlCol="0">
+                <a:spAutoFit/>
+              </a:bodyPr>
+              <a:lstStyle/>
+              <a:p>
+                <a:pPr algn="just"/>
+                <a:endParaRPr lang="en-US" sz="1200" b="1" i="1" dirty="0">
+                  <a:latin typeface="Arial" panose="020B0604020202020204" pitchFamily="34" charset="0"/>
+                  <a:cs typeface="Arial" panose="020B0604020202020204" pitchFamily="34" charset="0"/>
+                </a:endParaRPr>
+              </a:p>
+              <a:p>
+                <a:pPr algn="just"/>
+                <a:r>
+                  <a:rPr lang="en-US" sz="1200" b="1" i="1" dirty="0">
+                    <a:latin typeface="Arial" panose="020B0604020202020204" pitchFamily="34" charset="0"/>
+                    <a:cs typeface="Arial" panose="020B0604020202020204" pitchFamily="34" charset="0"/>
+                  </a:rPr>
+                  <a:t>Comment results: Try to classify the resonances, in which case are you close to critical coupling? Why?</a:t>
+                </a:r>
+              </a:p>
+              <a:p>
+                <a:pPr algn="just"/>
+                <a:endParaRPr lang="en-US" sz="1200" b="1" i="1" dirty="0">
+                  <a:latin typeface="Arial" panose="020B0604020202020204" pitchFamily="34" charset="0"/>
+                  <a:cs typeface="Arial" panose="020B0604020202020204" pitchFamily="34" charset="0"/>
+                </a:endParaRPr>
+              </a:p>
+              <a:p>
+                <a:pPr algn="just"/>
+                <a:r>
+                  <a:rPr lang="en-US" sz="1200" dirty="0">
+                    <a:latin typeface="Arial" panose="020B0604020202020204" pitchFamily="34" charset="0"/>
+                    <a:cs typeface="Arial" panose="020B0604020202020204" pitchFamily="34" charset="0"/>
+                  </a:rPr>
+                  <a:t>A</a:t>
+                </a:r>
+                <a:r>
+                  <a:rPr lang="es-ES" sz="1200" dirty="0">
+                    <a:latin typeface="Arial" panose="020B0604020202020204" pitchFamily="34" charset="0"/>
+                    <a:cs typeface="Arial" panose="020B0604020202020204" pitchFamily="34" charset="0"/>
+                  </a:rPr>
+                  <a:t>l cambiar </a:t>
+                </a:r>
+                <a14:m>
+                  <m:oMath xmlns:m="http://schemas.openxmlformats.org/officeDocument/2006/math">
+                    <m:r>
+                      <m:rPr>
+                        <m:sty m:val="p"/>
+                      </m:rPr>
+                      <a:rPr lang="es-ES" sz="1200" b="0" i="0"/>
+                      <m:t>K</m:t>
+                    </m:r>
+                  </m:oMath>
+                </a14:m>
+                <a:r>
+                  <a:rPr lang="es-ES" sz="1200" dirty="0">
+                    <a:latin typeface="Arial" panose="020B0604020202020204" pitchFamily="34" charset="0"/>
+                    <a:cs typeface="Arial" panose="020B0604020202020204" pitchFamily="34" charset="0"/>
+                  </a:rPr>
+                  <a:t>, cambia cuánta potencia se acopla al anillo. Para valores bajos, como </a:t>
+                </a:r>
+                <a14:m>
+                  <m:oMath xmlns:m="http://schemas.openxmlformats.org/officeDocument/2006/math">
+                    <m:r>
+                      <m:rPr>
+                        <m:sty m:val="p"/>
+                      </m:rPr>
+                      <a:rPr lang="es-ES" sz="1200" b="0" i="0"/>
+                      <m:t>K</m:t>
+                    </m:r>
+                    <m:r>
+                      <a:rPr lang="es-ES" sz="1200" b="0" i="0"/>
+                      <m:t>=</m:t>
+                    </m:r>
+                    <m:r>
+                      <a:rPr lang="es-ES" sz="1200" b="0" i="0"/>
+                      <m:t>0</m:t>
+                    </m:r>
+                    <m:r>
+                      <a:rPr lang="es-ES" sz="1200" b="0" i="0"/>
+                      <m:t>.</m:t>
+                    </m:r>
+                    <m:r>
+                      <a:rPr lang="es-ES" sz="1200" b="0" i="0"/>
+                      <m:t>1</m:t>
+                    </m:r>
+                  </m:oMath>
+                </a14:m>
+                <a:r>
+                  <a:rPr lang="es-ES" sz="1200" dirty="0">
+                    <a:latin typeface="Arial" panose="020B0604020202020204" pitchFamily="34" charset="0"/>
+                    <a:cs typeface="Arial" panose="020B0604020202020204" pitchFamily="34" charset="0"/>
+                  </a:rPr>
+                  <a:t> o y </a:t>
+                </a:r>
+                <a14:m>
+                  <m:oMath xmlns:m="http://schemas.openxmlformats.org/officeDocument/2006/math">
+                    <m:r>
+                      <m:rPr>
+                        <m:sty m:val="p"/>
+                      </m:rPr>
+                      <a:rPr lang="es-ES" sz="1200" b="0" i="0"/>
+                      <m:t>K</m:t>
+                    </m:r>
+                    <m:r>
+                      <a:rPr lang="es-ES" sz="1200" b="0" i="0"/>
+                      <m:t>=</m:t>
+                    </m:r>
+                    <m:r>
+                      <a:rPr lang="es-ES" sz="1200" b="0" i="0"/>
+                      <m:t>0</m:t>
+                    </m:r>
+                    <m:r>
+                      <a:rPr lang="es-ES" sz="1200" b="0" i="0"/>
+                      <m:t>.</m:t>
+                    </m:r>
+                    <m:r>
+                      <a:rPr lang="es-ES" sz="1200" b="0" i="0"/>
+                      <m:t>2</m:t>
+                    </m:r>
+                  </m:oMath>
+                </a14:m>
+                <a:r>
+                  <a:rPr lang="es-ES" sz="1200" dirty="0">
+                    <a:latin typeface="Arial" panose="020B0604020202020204" pitchFamily="34" charset="0"/>
+                    <a:cs typeface="Arial" panose="020B0604020202020204" pitchFamily="34" charset="0"/>
+                  </a:rPr>
+                  <a:t>, entra poca luz en el resonador, así que la caída de transmisión es pequeña y la resonancia es débil.</a:t>
+                </a:r>
+              </a:p>
+              <a:p>
+                <a:pPr algn="just"/>
+                <a:endParaRPr lang="es-ES" sz="1200" dirty="0">
+                  <a:latin typeface="Arial" panose="020B0604020202020204" pitchFamily="34" charset="0"/>
+                  <a:cs typeface="Arial" panose="020B0604020202020204" pitchFamily="34" charset="0"/>
+                </a:endParaRPr>
+              </a:p>
+              <a:p>
+                <a:pPr algn="just"/>
+                <a:r>
+                  <a:rPr lang="es-ES" sz="1200" dirty="0">
+                    <a:latin typeface="Arial" panose="020B0604020202020204" pitchFamily="34" charset="0"/>
+                    <a:cs typeface="Arial" panose="020B0604020202020204" pitchFamily="34" charset="0"/>
+                  </a:rPr>
+                  <a:t>Al aumentar </a:t>
+                </a:r>
+                <a14:m>
+                  <m:oMath xmlns:m="http://schemas.openxmlformats.org/officeDocument/2006/math">
+                    <m:r>
+                      <m:rPr>
+                        <m:sty m:val="p"/>
+                      </m:rPr>
+                      <a:rPr lang="es-ES" sz="1200" b="0" i="0"/>
+                      <m:t>K</m:t>
+                    </m:r>
+                  </m:oMath>
+                </a14:m>
+                <a:r>
+                  <a:rPr lang="es-ES" sz="1200" dirty="0">
+                    <a:latin typeface="Arial" panose="020B0604020202020204" pitchFamily="34" charset="0"/>
+                    <a:cs typeface="Arial" panose="020B0604020202020204" pitchFamily="34" charset="0"/>
+                  </a:rPr>
+                  <a:t>, el mínimo se hace más profundo porque se acopla más potencia al anillo. El caso más cercano al </a:t>
+                </a:r>
+                <a:r>
+                  <a:rPr lang="es-ES" sz="1200" dirty="0" err="1">
+                    <a:latin typeface="Arial" panose="020B0604020202020204" pitchFamily="34" charset="0"/>
+                    <a:cs typeface="Arial" panose="020B0604020202020204" pitchFamily="34" charset="0"/>
+                  </a:rPr>
+                  <a:t>critical</a:t>
+                </a:r>
+                <a:r>
+                  <a:rPr lang="es-ES" sz="1200" dirty="0">
+                    <a:latin typeface="Arial" panose="020B0604020202020204" pitchFamily="34" charset="0"/>
+                    <a:cs typeface="Arial" panose="020B0604020202020204" pitchFamily="34" charset="0"/>
+                  </a:rPr>
+                  <a:t> </a:t>
+                </a:r>
+                <a:r>
+                  <a:rPr lang="es-ES" sz="1200" dirty="0" err="1">
+                    <a:latin typeface="Arial" panose="020B0604020202020204" pitchFamily="34" charset="0"/>
+                    <a:cs typeface="Arial" panose="020B0604020202020204" pitchFamily="34" charset="0"/>
+                  </a:rPr>
+                  <a:t>coupling</a:t>
+                </a:r>
+                <a:r>
+                  <a:rPr lang="es-ES" sz="1200" dirty="0">
+                    <a:latin typeface="Arial" panose="020B0604020202020204" pitchFamily="34" charset="0"/>
+                    <a:cs typeface="Arial" panose="020B0604020202020204" pitchFamily="34" charset="0"/>
+                  </a:rPr>
+                  <a:t> es </a:t>
+                </a:r>
+                <a14:m>
+                  <m:oMath xmlns:m="http://schemas.openxmlformats.org/officeDocument/2006/math">
+                    <m:r>
+                      <m:rPr>
+                        <m:sty m:val="p"/>
+                      </m:rPr>
+                      <a:rPr lang="es-ES" sz="1200" b="0" i="0"/>
+                      <m:t>K</m:t>
+                    </m:r>
+                    <m:r>
+                      <a:rPr lang="es-ES" sz="1200" b="0" i="0"/>
+                      <m:t>=</m:t>
+                    </m:r>
+                    <m:r>
+                      <a:rPr lang="es-ES" sz="1200" b="0" i="0"/>
+                      <m:t>0</m:t>
+                    </m:r>
+                    <m:r>
+                      <a:rPr lang="es-ES" sz="1200" b="0" i="0"/>
+                      <m:t>.</m:t>
+                    </m:r>
+                    <m:r>
+                      <a:rPr lang="es-ES" sz="1200" b="0" i="0"/>
+                      <m:t>3</m:t>
+                    </m:r>
+                  </m:oMath>
+                </a14:m>
+                <a:r>
+                  <a:rPr lang="es-ES" sz="1200" dirty="0">
+                    <a:latin typeface="Arial" panose="020B0604020202020204" pitchFamily="34" charset="0"/>
+                    <a:cs typeface="Arial" panose="020B0604020202020204" pitchFamily="34" charset="0"/>
+                  </a:rPr>
+                  <a:t>,  porque en ese punto el acoplo hacia el anillo se compensa mejor con las pérdidas internas del resonador. Así se consigue una cancelación más fuerte en la salida.</a:t>
+                </a:r>
+              </a:p>
+              <a:p>
+                <a:pPr algn="just"/>
+                <a:endParaRPr lang="es-ES" sz="1200" dirty="0">
+                  <a:latin typeface="Arial" panose="020B0604020202020204" pitchFamily="34" charset="0"/>
+                  <a:cs typeface="Arial" panose="020B0604020202020204" pitchFamily="34" charset="0"/>
+                </a:endParaRPr>
+              </a:p>
+              <a:p>
+                <a:pPr algn="just"/>
+                <a:r>
+                  <a:rPr lang="es-ES" sz="1200" dirty="0">
+                    <a:latin typeface="Arial" panose="020B0604020202020204" pitchFamily="34" charset="0"/>
+                    <a:cs typeface="Arial" panose="020B0604020202020204" pitchFamily="34" charset="0"/>
+                  </a:rPr>
+                  <a:t>Para valores mayores de </a:t>
+                </a:r>
+                <a14:m>
+                  <m:oMath xmlns:m="http://schemas.openxmlformats.org/officeDocument/2006/math">
+                    <m:r>
+                      <m:rPr>
+                        <m:sty m:val="p"/>
+                      </m:rPr>
+                      <a:rPr lang="es-ES" sz="1200" b="0" i="0"/>
+                      <m:t>K</m:t>
+                    </m:r>
+                  </m:oMath>
+                </a14:m>
+                <a:r>
+                  <a:rPr lang="es-ES" sz="1200" dirty="0">
+                    <a:latin typeface="Arial" panose="020B0604020202020204" pitchFamily="34" charset="0"/>
+                    <a:cs typeface="Arial" panose="020B0604020202020204" pitchFamily="34" charset="0"/>
+                  </a:rPr>
+                  <a:t> como </a:t>
+                </a:r>
+                <a14:m>
+                  <m:oMath xmlns:m="http://schemas.openxmlformats.org/officeDocument/2006/math">
+                    <m:r>
+                      <m:rPr>
+                        <m:sty m:val="p"/>
+                      </m:rPr>
+                      <a:rPr lang="es-ES" sz="1200">
+                        <a:latin typeface="Cambria Math" panose="02040503050406030204" pitchFamily="18" charset="0"/>
+                      </a:rPr>
+                      <m:t>K</m:t>
+                    </m:r>
+                    <m:r>
+                      <a:rPr lang="es-ES" sz="1200">
+                        <a:latin typeface="Cambria Math" panose="02040503050406030204" pitchFamily="18" charset="0"/>
+                      </a:rPr>
+                      <m:t>=</m:t>
+                    </m:r>
+                    <m:r>
+                      <a:rPr lang="es-ES" sz="1200">
+                        <a:latin typeface="Cambria Math" panose="02040503050406030204" pitchFamily="18" charset="0"/>
+                      </a:rPr>
+                      <m:t>0</m:t>
+                    </m:r>
+                    <m:r>
+                      <a:rPr lang="es-ES" sz="1200">
+                        <a:latin typeface="Cambria Math" panose="02040503050406030204" pitchFamily="18" charset="0"/>
+                      </a:rPr>
+                      <m:t>.</m:t>
+                    </m:r>
+                    <m:r>
+                      <a:rPr lang="es-ES" sz="1200" b="0" i="0" smtClean="0">
+                        <a:latin typeface="Cambria Math" panose="02040503050406030204" pitchFamily="18" charset="0"/>
+                      </a:rPr>
+                      <m:t>7</m:t>
+                    </m:r>
+                  </m:oMath>
+                </a14:m>
+                <a:r>
+                  <a:rPr lang="es-ES" sz="1200" dirty="0">
+                    <a:latin typeface="Arial" panose="020B0604020202020204" pitchFamily="34" charset="0"/>
+                    <a:cs typeface="Arial" panose="020B0604020202020204" pitchFamily="34" charset="0"/>
+                  </a:rPr>
+                  <a:t> o </a:t>
+                </a:r>
+                <a14:m>
+                  <m:oMath xmlns:m="http://schemas.openxmlformats.org/officeDocument/2006/math">
+                    <m:r>
+                      <m:rPr>
+                        <m:sty m:val="p"/>
+                      </m:rPr>
+                      <a:rPr lang="es-ES" sz="1200">
+                        <a:latin typeface="Cambria Math" panose="02040503050406030204" pitchFamily="18" charset="0"/>
+                      </a:rPr>
+                      <m:t>K</m:t>
+                    </m:r>
+                    <m:r>
+                      <a:rPr lang="es-ES" sz="1200">
+                        <a:latin typeface="Cambria Math" panose="02040503050406030204" pitchFamily="18" charset="0"/>
+                      </a:rPr>
+                      <m:t>=</m:t>
+                    </m:r>
+                    <m:r>
+                      <a:rPr lang="es-ES" sz="1200">
+                        <a:latin typeface="Cambria Math" panose="02040503050406030204" pitchFamily="18" charset="0"/>
+                      </a:rPr>
+                      <m:t>0</m:t>
+                    </m:r>
+                    <m:r>
+                      <a:rPr lang="es-ES" sz="1200">
+                        <a:latin typeface="Cambria Math" panose="02040503050406030204" pitchFamily="18" charset="0"/>
+                      </a:rPr>
+                      <m:t>.</m:t>
+                    </m:r>
+                    <m:r>
+                      <a:rPr lang="es-ES" sz="1200" b="0" i="0" smtClean="0">
+                        <a:latin typeface="Cambria Math" panose="02040503050406030204" pitchFamily="18" charset="0"/>
+                      </a:rPr>
+                      <m:t>8</m:t>
+                    </m:r>
+                  </m:oMath>
+                </a14:m>
+                <a:r>
+                  <a:rPr lang="es-ES" sz="1200" dirty="0">
+                    <a:latin typeface="Arial" panose="020B0604020202020204" pitchFamily="34" charset="0"/>
+                    <a:cs typeface="Arial" panose="020B0604020202020204" pitchFamily="34" charset="0"/>
+                  </a:rPr>
+                  <a:t>, </a:t>
+                </a:r>
+                <a14:m>
+                  <m:oMath xmlns:m="http://schemas.openxmlformats.org/officeDocument/2006/math">
+                    <m:r>
+                      <m:rPr>
+                        <m:sty m:val="p"/>
+                      </m:rPr>
+                      <a:rPr lang="es-ES" sz="1200">
+                        <a:latin typeface="Cambria Math" panose="02040503050406030204" pitchFamily="18" charset="0"/>
+                      </a:rPr>
+                      <m:t>K</m:t>
+                    </m:r>
+                    <m:r>
+                      <a:rPr lang="es-ES" sz="1200">
+                        <a:latin typeface="Cambria Math" panose="02040503050406030204" pitchFamily="18" charset="0"/>
+                      </a:rPr>
+                      <m:t>=</m:t>
+                    </m:r>
+                    <m:r>
+                      <a:rPr lang="es-ES" sz="1200">
+                        <a:latin typeface="Cambria Math" panose="02040503050406030204" pitchFamily="18" charset="0"/>
+                      </a:rPr>
+                      <m:t>0</m:t>
+                    </m:r>
+                    <m:r>
+                      <a:rPr lang="es-ES" sz="1200">
+                        <a:latin typeface="Cambria Math" panose="02040503050406030204" pitchFamily="18" charset="0"/>
+                      </a:rPr>
+                      <m:t>.</m:t>
+                    </m:r>
+                    <m:r>
+                      <a:rPr lang="es-ES" sz="1200" b="0" i="0" smtClean="0">
+                        <a:latin typeface="Cambria Math" panose="02040503050406030204" pitchFamily="18" charset="0"/>
+                      </a:rPr>
+                      <m:t>9</m:t>
+                    </m:r>
+                  </m:oMath>
+                </a14:m>
+                <a:r>
+                  <a:rPr lang="es-ES" sz="1200" dirty="0">
+                    <a:latin typeface="Arial" panose="020B0604020202020204" pitchFamily="34" charset="0"/>
+                    <a:cs typeface="Arial" panose="020B0604020202020204" pitchFamily="34" charset="0"/>
+                  </a:rPr>
+                  <a:t> la resonancia vuelve a ser menos profunda, porque se supera el punto óptimo de acoplo y el anillo queda </a:t>
+                </a:r>
+                <a:r>
+                  <a:rPr lang="es-ES" sz="1200" dirty="0" err="1">
+                    <a:latin typeface="Arial" panose="020B0604020202020204" pitchFamily="34" charset="0"/>
+                    <a:cs typeface="Arial" panose="020B0604020202020204" pitchFamily="34" charset="0"/>
+                  </a:rPr>
+                  <a:t>sobreacoplado</a:t>
+                </a:r>
+                <a:r>
+                  <a:rPr lang="es-ES" sz="1200" dirty="0">
+                    <a:latin typeface="Arial" panose="020B0604020202020204" pitchFamily="34" charset="0"/>
+                    <a:cs typeface="Arial" panose="020B0604020202020204" pitchFamily="34" charset="0"/>
+                  </a:rPr>
+                  <a:t>. Aun así, se ve que una </a:t>
+                </a:r>
+                <a14:m>
+                  <m:oMath xmlns:m="http://schemas.openxmlformats.org/officeDocument/2006/math">
+                    <m:r>
+                      <m:rPr>
+                        <m:sty m:val="p"/>
+                      </m:rPr>
+                      <a:rPr lang="es-ES" sz="1200" b="0" i="0"/>
+                      <m:t>K</m:t>
+                    </m:r>
+                  </m:oMath>
+                </a14:m>
+                <a:r>
+                  <a:rPr lang="es-ES" sz="1200" dirty="0">
+                    <a:latin typeface="Arial" panose="020B0604020202020204" pitchFamily="34" charset="0"/>
+                    <a:cs typeface="Arial" panose="020B0604020202020204" pitchFamily="34" charset="0"/>
+                  </a:rPr>
+                  <a:t> baja suele dar mejor contraste que una </a:t>
+                </a:r>
+                <a14:m>
+                  <m:oMath xmlns:m="http://schemas.openxmlformats.org/officeDocument/2006/math">
+                    <m:r>
+                      <m:rPr>
+                        <m:sty m:val="p"/>
+                      </m:rPr>
+                      <a:rPr lang="es-ES" sz="1200" b="0" i="0"/>
+                      <m:t>K</m:t>
+                    </m:r>
+                  </m:oMath>
+                </a14:m>
+                <a:r>
+                  <a:rPr lang="es-ES" sz="1200" dirty="0">
+                    <a:latin typeface="Arial" panose="020B0604020202020204" pitchFamily="34" charset="0"/>
+                    <a:cs typeface="Arial" panose="020B0604020202020204" pitchFamily="34" charset="0"/>
+                  </a:rPr>
+                  <a:t> muy alta, porque con </a:t>
+                </a:r>
+                <a14:m>
+                  <m:oMath xmlns:m="http://schemas.openxmlformats.org/officeDocument/2006/math">
+                    <m:r>
+                      <m:rPr>
+                        <m:sty m:val="p"/>
+                      </m:rPr>
+                      <a:rPr lang="es-ES" sz="1200" b="0" i="0"/>
+                      <m:t>K</m:t>
+                    </m:r>
+                    <m:r>
+                      <a:rPr lang="es-ES" sz="1200" b="0" i="0" smtClean="0">
+                        <a:latin typeface="Cambria Math" panose="02040503050406030204" pitchFamily="18" charset="0"/>
+                      </a:rPr>
+                      <m:t> </m:t>
+                    </m:r>
+                  </m:oMath>
+                </a14:m>
+                <a:r>
+                  <a:rPr lang="es-ES" sz="1200" dirty="0">
+                    <a:latin typeface="Arial" panose="020B0604020202020204" pitchFamily="34" charset="0"/>
+                    <a:cs typeface="Arial" panose="020B0604020202020204" pitchFamily="34" charset="0"/>
+                  </a:rPr>
+                  <a:t>muy alta el acoplo es excesivo y la cancelación empeora y el mínimo de transmisión sube. </a:t>
+                </a:r>
+              </a:p>
+              <a:p>
+                <a:pPr algn="just"/>
+                <a:r>
+                  <a:rPr lang="es-ES" sz="1200" dirty="0">
+                    <a:latin typeface="Arial" panose="020B0604020202020204" pitchFamily="34" charset="0"/>
+                    <a:cs typeface="Arial" panose="020B0604020202020204" pitchFamily="34" charset="0"/>
+                  </a:rPr>
+                  <a:t>Por todo esto, concluimos que el mejor resultado es aproximadamente</a:t>
+                </a:r>
+                <a:endParaRPr lang="es-ES" sz="1200" b="0" i="0" dirty="0">
+                  <a:latin typeface="Arial" panose="020B0604020202020204" pitchFamily="34" charset="0"/>
+                  <a:cs typeface="Arial" panose="020B0604020202020204" pitchFamily="34" charset="0"/>
+                </a:endParaRPr>
+              </a:p>
+              <a:p>
+                <a:pPr algn="just"/>
+                <a14:m>
+                  <m:oMath xmlns:m="http://schemas.openxmlformats.org/officeDocument/2006/math">
+                    <m:r>
+                      <m:rPr>
+                        <m:sty m:val="p"/>
+                      </m:rPr>
+                      <a:rPr lang="es-ES" sz="1200" b="0" i="0"/>
+                      <m:t>K</m:t>
+                    </m:r>
+                    <m:r>
+                      <a:rPr lang="es-ES" sz="1200" b="0" i="0"/>
+                      <m:t>=</m:t>
+                    </m:r>
+                    <m:r>
+                      <a:rPr lang="es-ES" sz="1200" b="0" i="0"/>
+                      <m:t>0</m:t>
+                    </m:r>
+                    <m:r>
+                      <a:rPr lang="es-ES" sz="1200" b="0" i="0"/>
+                      <m:t>.</m:t>
+                    </m:r>
+                    <m:r>
+                      <a:rPr lang="es-ES" sz="1200" b="0" i="0"/>
+                      <m:t>3</m:t>
+                    </m:r>
+                  </m:oMath>
+                </a14:m>
+                <a:r>
+                  <a:rPr lang="es-ES" sz="1200" dirty="0">
+                    <a:latin typeface="Arial" panose="020B0604020202020204" pitchFamily="34" charset="0"/>
+                    <a:cs typeface="Arial" panose="020B0604020202020204" pitchFamily="34" charset="0"/>
+                  </a:rPr>
+                  <a:t>.</a:t>
+                </a:r>
+              </a:p>
+              <a:p>
+                <a:pPr algn="just"/>
+                <a:endParaRPr lang="en-US" sz="1200" dirty="0">
+                  <a:latin typeface="Arial" panose="020B0604020202020204" pitchFamily="34" charset="0"/>
+                  <a:cs typeface="Arial" panose="020B0604020202020204" pitchFamily="34" charset="0"/>
+                </a:endParaRPr>
+              </a:p>
+            </p:txBody>
+          </p:sp>
+        </mc:Choice>
+        <mc:Fallback>
+          <p:sp>
+            <p:nvSpPr>
+              <p:cNvPr id="7" name="CuadroTexto 6">
+                <a:extLst>
+                  <a:ext uri="{FF2B5EF4-FFF2-40B4-BE49-F238E27FC236}">
+                    <a16:creationId xmlns:a16="http://schemas.microsoft.com/office/drawing/2014/main" id="{3B4E8CED-CB99-A17B-0D7A-6C4D30ADE644}"/>
+                  </a:ext>
+                </a:extLst>
+              </p:cNvPr>
+              <p:cNvSpPr txBox="1">
+                <a:spLocks noRot="1" noChangeAspect="1" noMove="1" noResize="1" noEditPoints="1" noAdjustHandles="1" noChangeArrowheads="1" noChangeShapeType="1" noTextEdit="1"/>
+              </p:cNvSpPr>
+              <p:nvPr/>
+            </p:nvSpPr>
+            <p:spPr>
+              <a:xfrm>
+                <a:off x="6553200" y="1419036"/>
+                <a:ext cx="5127010" cy="4339650"/>
+              </a:xfrm>
+              <a:prstGeom prst="rect">
+                <a:avLst/>
+              </a:prstGeom>
+              <a:blipFill>
+                <a:blip r:embed="rId4"/>
+                <a:stretch>
+                  <a:fillRect/>
+                </a:stretch>
+              </a:blipFill>
+              <a:ln w="28575">
+                <a:solidFill>
+                  <a:srgbClr val="E0700D"/>
+                </a:solidFill>
+              </a:ln>
+            </p:spPr>
+            <p:txBody>
+              <a:bodyPr/>
+              <a:lstStyle/>
+              <a:p>
+                <a:r>
+                  <a:rPr lang="es-ES">
+                    <a:noFill/>
+                  </a:rPr>
+                  <a:t> </a:t>
+                </a:r>
+              </a:p>
+            </p:txBody>
+          </p:sp>
+        </mc:Fallback>
+      </mc:AlternateContent>
     </p:spTree>
     <p:extLst>
       <p:ext uri="{BB962C8B-B14F-4D97-AF65-F5344CB8AC3E}">
@@ -7101,81 +7496,321 @@
           </a:p>
         </p:txBody>
       </p:sp>
-      <p:sp>
-        <p:nvSpPr>
-          <p:cNvPr id="8" name="CuadroTexto 7">
+      <mc:AlternateContent xmlns:mc="http://schemas.openxmlformats.org/markup-compatibility/2006">
+        <mc:Choice xmlns:a14="http://schemas.microsoft.com/office/drawing/2010/main" Requires="a14">
+          <p:sp>
+            <p:nvSpPr>
+              <p:cNvPr id="8" name="CuadroTexto 7">
+                <a:extLst>
+                  <a:ext uri="{FF2B5EF4-FFF2-40B4-BE49-F238E27FC236}">
+                    <a16:creationId xmlns:a16="http://schemas.microsoft.com/office/drawing/2014/main" id="{D9601617-351E-AE1A-1F4D-693F2EA59361}"/>
+                  </a:ext>
+                </a:extLst>
+              </p:cNvPr>
+              <p:cNvSpPr txBox="1"/>
+              <p:nvPr/>
+            </p:nvSpPr>
+            <p:spPr>
+              <a:xfrm>
+                <a:off x="7391400" y="1421483"/>
+                <a:ext cx="4063181" cy="4154984"/>
+              </a:xfrm>
+              <a:prstGeom prst="rect">
+                <a:avLst/>
+              </a:prstGeom>
+              <a:solidFill>
+                <a:schemeClr val="bg1">
+                  <a:lumMod val="95000"/>
+                </a:schemeClr>
+              </a:solidFill>
+              <a:ln w="28575">
+                <a:solidFill>
+                  <a:srgbClr val="E0700D"/>
+                </a:solidFill>
+              </a:ln>
+            </p:spPr>
+            <p:txBody>
+              <a:bodyPr wrap="square" rtlCol="0">
+                <a:spAutoFit/>
+              </a:bodyPr>
+              <a:lstStyle/>
+              <a:p>
+                <a:pPr algn="just"/>
+                <a:endParaRPr lang="en-US" sz="1200" b="1" i="1" dirty="0">
+                  <a:latin typeface="Arial" panose="020B0604020202020204" pitchFamily="34" charset="0"/>
+                  <a:cs typeface="Arial" panose="020B0604020202020204" pitchFamily="34" charset="0"/>
+                </a:endParaRPr>
+              </a:p>
+              <a:p>
+                <a:pPr algn="just"/>
+                <a:r>
+                  <a:rPr lang="en-US" sz="1200" b="1" i="1" dirty="0">
+                    <a:latin typeface="Arial" panose="020B0604020202020204" pitchFamily="34" charset="0"/>
+                    <a:cs typeface="Arial" panose="020B0604020202020204" pitchFamily="34" charset="0"/>
+                  </a:rPr>
+                  <a:t>Comment results. Try to classify the resonances, in which case are you close to critical coupling? Why?</a:t>
+                </a:r>
+              </a:p>
+              <a:p>
+                <a:pPr algn="just"/>
+                <a:endParaRPr lang="en-US" sz="1200" dirty="0">
+                  <a:latin typeface="Arial" panose="020B0604020202020204" pitchFamily="34" charset="0"/>
+                  <a:cs typeface="Arial" panose="020B0604020202020204" pitchFamily="34" charset="0"/>
+                </a:endParaRPr>
+              </a:p>
+              <a:p>
+                <a:pPr algn="just"/>
+                <a:r>
+                  <a:rPr lang="es-ES" sz="1200" dirty="0">
+                    <a:latin typeface="Arial" panose="020B0604020202020204" pitchFamily="34" charset="0"/>
+                    <a:cs typeface="Arial" panose="020B0604020202020204" pitchFamily="34" charset="0"/>
+                  </a:rPr>
+                  <a:t>Al aumentar las pérdidas del anillo, la resonancia cambia de profundidad. Para pérdidas bajas, como </a:t>
+                </a:r>
+                <a14:m>
+                  <m:oMath xmlns:m="http://schemas.openxmlformats.org/officeDocument/2006/math">
+                    <m:r>
+                      <m:rPr>
+                        <m:sty m:val="p"/>
+                      </m:rPr>
+                      <a:rPr lang="es-ES" sz="1200" b="0" i="0"/>
+                      <m:t>α</m:t>
+                    </m:r>
+                    <m:r>
+                      <a:rPr lang="es-ES" sz="1200" b="0" i="0"/>
+                      <m:t>=0</m:t>
+                    </m:r>
+                  </m:oMath>
+                </a14:m>
+                <a:r>
+                  <a:rPr lang="es-ES" sz="1200" dirty="0">
+                    <a:latin typeface="Arial" panose="020B0604020202020204" pitchFamily="34" charset="0"/>
+                    <a:cs typeface="Arial" panose="020B0604020202020204" pitchFamily="34" charset="0"/>
+                  </a:rPr>
+                  <a:t>o </a:t>
+                </a:r>
+                <a14:m>
+                  <m:oMath xmlns:m="http://schemas.openxmlformats.org/officeDocument/2006/math">
+                    <m:r>
+                      <a:rPr lang="es-ES" sz="1200" b="0" i="0"/>
+                      <m:t>1</m:t>
+                    </m:r>
+                    <m:r>
+                      <m:rPr>
+                        <m:nor/>
+                      </m:rPr>
+                      <a:rPr lang="es-ES" sz="1200">
+                        <a:latin typeface="Arial" panose="020B0604020202020204" pitchFamily="34" charset="0"/>
+                        <a:cs typeface="Arial" panose="020B0604020202020204" pitchFamily="34" charset="0"/>
+                      </a:rPr>
+                      <m:t> </m:t>
+                    </m:r>
+                    <m:r>
+                      <m:rPr>
+                        <m:sty m:val="p"/>
+                      </m:rPr>
+                      <a:rPr lang="es-ES" sz="1200" b="0" i="0"/>
+                      <m:t>dB</m:t>
+                    </m:r>
+                    <m:r>
+                      <a:rPr lang="es-ES" sz="1200" b="0" i="0"/>
+                      <m:t>/</m:t>
+                    </m:r>
+                    <m:r>
+                      <m:rPr>
+                        <m:sty m:val="p"/>
+                      </m:rPr>
+                      <a:rPr lang="es-ES" sz="1200" b="0" i="0"/>
+                      <m:t>cm</m:t>
+                    </m:r>
+                  </m:oMath>
+                </a14:m>
+                <a:r>
+                  <a:rPr lang="es-ES" sz="1200" dirty="0">
+                    <a:latin typeface="Arial" panose="020B0604020202020204" pitchFamily="34" charset="0"/>
+                    <a:cs typeface="Arial" panose="020B0604020202020204" pitchFamily="34" charset="0"/>
+                  </a:rPr>
+                  <a:t>, la caída es pequeña porque las pérdidas internas del anillo son bajas y no se compensan bien con el acoplo hacia la guía.</a:t>
+                </a:r>
+              </a:p>
+              <a:p>
+                <a:pPr algn="just"/>
+                <a:endParaRPr lang="es-ES" sz="1200" dirty="0">
+                  <a:latin typeface="Arial" panose="020B0604020202020204" pitchFamily="34" charset="0"/>
+                  <a:cs typeface="Arial" panose="020B0604020202020204" pitchFamily="34" charset="0"/>
+                </a:endParaRPr>
+              </a:p>
+              <a:p>
+                <a:pPr algn="just"/>
+                <a:r>
+                  <a:rPr lang="es-ES" sz="1200" dirty="0">
+                    <a:latin typeface="Arial" panose="020B0604020202020204" pitchFamily="34" charset="0"/>
+                    <a:cs typeface="Arial" panose="020B0604020202020204" pitchFamily="34" charset="0"/>
+                  </a:rPr>
+                  <a:t>Cuando las pérdidas aumentan, la transmisión en resonancia baja más. Esto significa que hay más cancelación en la salida, porque las pérdidas internas del anillo se van equilibrando mejor con el acoplo.</a:t>
+                </a:r>
+              </a:p>
+              <a:p>
+                <a:pPr algn="just"/>
+                <a:endParaRPr lang="es-ES" sz="1200" dirty="0">
+                  <a:latin typeface="Arial" panose="020B0604020202020204" pitchFamily="34" charset="0"/>
+                  <a:cs typeface="Arial" panose="020B0604020202020204" pitchFamily="34" charset="0"/>
+                </a:endParaRPr>
+              </a:p>
+              <a:p>
+                <a:pPr algn="just"/>
+                <a:r>
+                  <a:rPr lang="es-ES" sz="1200" dirty="0">
+                    <a:latin typeface="Arial" panose="020B0604020202020204" pitchFamily="34" charset="0"/>
+                    <a:cs typeface="Arial" panose="020B0604020202020204" pitchFamily="34" charset="0"/>
+                  </a:rPr>
+                  <a:t>El caso más cercano al </a:t>
+                </a:r>
+                <a:r>
+                  <a:rPr lang="es-ES" sz="1200" dirty="0" err="1">
+                    <a:latin typeface="Arial" panose="020B0604020202020204" pitchFamily="34" charset="0"/>
+                    <a:cs typeface="Arial" panose="020B0604020202020204" pitchFamily="34" charset="0"/>
+                  </a:rPr>
+                  <a:t>critical</a:t>
+                </a:r>
+                <a:r>
+                  <a:rPr lang="es-ES" sz="1200" dirty="0">
+                    <a:latin typeface="Arial" panose="020B0604020202020204" pitchFamily="34" charset="0"/>
+                    <a:cs typeface="Arial" panose="020B0604020202020204" pitchFamily="34" charset="0"/>
+                  </a:rPr>
+                  <a:t> </a:t>
+                </a:r>
+                <a:r>
+                  <a:rPr lang="es-ES" sz="1200" dirty="0" err="1">
+                    <a:latin typeface="Arial" panose="020B0604020202020204" pitchFamily="34" charset="0"/>
+                    <a:cs typeface="Arial" panose="020B0604020202020204" pitchFamily="34" charset="0"/>
+                  </a:rPr>
+                  <a:t>coupling</a:t>
+                </a:r>
+                <a:r>
+                  <a:rPr lang="es-ES" sz="1200" dirty="0">
+                    <a:latin typeface="Arial" panose="020B0604020202020204" pitchFamily="34" charset="0"/>
+                    <a:cs typeface="Arial" panose="020B0604020202020204" pitchFamily="34" charset="0"/>
+                  </a:rPr>
+                  <a:t> es aproximadamente </a:t>
+                </a:r>
+                <a14:m>
+                  <m:oMath xmlns:m="http://schemas.openxmlformats.org/officeDocument/2006/math">
+                    <m:r>
+                      <m:rPr>
+                        <m:sty m:val="p"/>
+                      </m:rPr>
+                      <a:rPr lang="es-ES" sz="1200" b="0" i="0"/>
+                      <m:t>α</m:t>
+                    </m:r>
+                    <m:r>
+                      <a:rPr lang="es-ES" sz="1200" b="0" i="0"/>
+                      <m:t>=8</m:t>
+                    </m:r>
+                    <m:r>
+                      <m:rPr>
+                        <m:nor/>
+                      </m:rPr>
+                      <a:rPr lang="es-ES" sz="1200">
+                        <a:latin typeface="Arial" panose="020B0604020202020204" pitchFamily="34" charset="0"/>
+                        <a:cs typeface="Arial" panose="020B0604020202020204" pitchFamily="34" charset="0"/>
+                      </a:rPr>
+                      <m:t> </m:t>
+                    </m:r>
+                    <m:r>
+                      <m:rPr>
+                        <m:sty m:val="p"/>
+                      </m:rPr>
+                      <a:rPr lang="es-ES" sz="1200" b="0" i="0"/>
+                      <m:t>dB</m:t>
+                    </m:r>
+                    <m:r>
+                      <a:rPr lang="es-ES" sz="1200" b="0" i="0"/>
+                      <m:t>/</m:t>
+                    </m:r>
+                    <m:r>
+                      <m:rPr>
+                        <m:sty m:val="p"/>
+                      </m:rPr>
+                      <a:rPr lang="es-ES" sz="1200" b="0" i="0"/>
+                      <m:t>cm</m:t>
+                    </m:r>
+                  </m:oMath>
+                </a14:m>
+                <a:r>
+                  <a:rPr lang="es-ES" sz="1200" dirty="0">
+                    <a:latin typeface="Arial" panose="020B0604020202020204" pitchFamily="34" charset="0"/>
+                    <a:cs typeface="Arial" panose="020B0604020202020204" pitchFamily="34" charset="0"/>
+                  </a:rPr>
+                  <a:t>, ya que es donde se obtiene el mínimo de transmisión más bajo. En ese punto, el acoplo y las pérdidas internas están más compensados, por eso la resonancia tiene mayor contraste.</a:t>
+                </a:r>
+              </a:p>
+              <a:p>
+                <a:pPr algn="just"/>
+                <a:endParaRPr lang="en-US" sz="1200" dirty="0">
+                  <a:latin typeface="Arial" panose="020B0604020202020204" pitchFamily="34" charset="0"/>
+                  <a:cs typeface="Arial" panose="020B0604020202020204" pitchFamily="34" charset="0"/>
+                </a:endParaRPr>
+              </a:p>
+            </p:txBody>
+          </p:sp>
+        </mc:Choice>
+        <mc:Fallback>
+          <p:sp>
+            <p:nvSpPr>
+              <p:cNvPr id="8" name="CuadroTexto 7">
+                <a:extLst>
+                  <a:ext uri="{FF2B5EF4-FFF2-40B4-BE49-F238E27FC236}">
+                    <a16:creationId xmlns:a16="http://schemas.microsoft.com/office/drawing/2014/main" id="{D9601617-351E-AE1A-1F4D-693F2EA59361}"/>
+                  </a:ext>
+                </a:extLst>
+              </p:cNvPr>
+              <p:cNvSpPr txBox="1">
+                <a:spLocks noRot="1" noChangeAspect="1" noMove="1" noResize="1" noEditPoints="1" noAdjustHandles="1" noChangeArrowheads="1" noChangeShapeType="1" noTextEdit="1"/>
+              </p:cNvSpPr>
+              <p:nvPr/>
+            </p:nvSpPr>
+            <p:spPr>
+              <a:xfrm>
+                <a:off x="7391400" y="1421483"/>
+                <a:ext cx="4063181" cy="4154984"/>
+              </a:xfrm>
+              <a:prstGeom prst="rect">
+                <a:avLst/>
+              </a:prstGeom>
+              <a:blipFill>
+                <a:blip r:embed="rId2"/>
+                <a:stretch>
+                  <a:fillRect/>
+                </a:stretch>
+              </a:blipFill>
+              <a:ln w="28575">
+                <a:solidFill>
+                  <a:srgbClr val="E0700D"/>
+                </a:solidFill>
+              </a:ln>
+            </p:spPr>
+            <p:txBody>
+              <a:bodyPr/>
+              <a:lstStyle/>
+              <a:p>
+                <a:r>
+                  <a:rPr lang="es-ES">
+                    <a:noFill/>
+                  </a:rPr>
+                  <a:t> </a:t>
+                </a:r>
+              </a:p>
+            </p:txBody>
+          </p:sp>
+        </mc:Fallback>
+      </mc:AlternateContent>
+      <p:sp>
+        <p:nvSpPr>
+          <p:cNvPr id="9" name="Rectángulo 8">
             <a:extLst>
               <a:ext uri="{FF2B5EF4-FFF2-40B4-BE49-F238E27FC236}">
-                <a16:creationId xmlns:a16="http://schemas.microsoft.com/office/drawing/2014/main" id="{D9601617-351E-AE1A-1F4D-693F2EA59361}"/>
-              </a:ext>
-            </a:extLst>
-          </p:cNvPr>
-          <p:cNvSpPr txBox="1"/>
-          <p:nvPr/>
-        </p:nvSpPr>
-        <p:spPr>
-          <a:xfrm>
-            <a:off x="611029" y="4860335"/>
-            <a:ext cx="11199530" cy="830997"/>
-          </a:xfrm>
-          <a:prstGeom prst="rect">
-            <a:avLst/>
-          </a:prstGeom>
-          <a:solidFill>
-            <a:schemeClr val="bg1">
-              <a:lumMod val="95000"/>
-            </a:schemeClr>
-          </a:solidFill>
-          <a:ln w="28575">
-            <a:solidFill>
-              <a:srgbClr val="E0700D"/>
-            </a:solidFill>
-          </a:ln>
-        </p:spPr>
-        <p:txBody>
-          <a:bodyPr wrap="square" rtlCol="0">
-            <a:spAutoFit/>
-          </a:bodyPr>
-          <a:lstStyle/>
-          <a:p>
-            <a:pPr algn="just"/>
-            <a:r>
-              <a:rPr lang="en-US" sz="1200" dirty="0">
-                <a:latin typeface="Arial" panose="020B0604020202020204" pitchFamily="34" charset="0"/>
-                <a:cs typeface="Arial" panose="020B0604020202020204" pitchFamily="34" charset="0"/>
-              </a:rPr>
-              <a:t>Comment results. Try to classify the resonances, in which case are you close to critical coupling? Why?</a:t>
-            </a:r>
-          </a:p>
-          <a:p>
-            <a:pPr algn="just"/>
-            <a:endParaRPr lang="en-US" sz="1200" dirty="0">
-              <a:latin typeface="Arial" panose="020B0604020202020204" pitchFamily="34" charset="0"/>
-              <a:cs typeface="Arial" panose="020B0604020202020204" pitchFamily="34" charset="0"/>
-            </a:endParaRPr>
-          </a:p>
-          <a:p>
-            <a:pPr algn="just"/>
-            <a:endParaRPr lang="en-US" sz="1200" dirty="0">
-              <a:latin typeface="Arial" panose="020B0604020202020204" pitchFamily="34" charset="0"/>
-              <a:cs typeface="Arial" panose="020B0604020202020204" pitchFamily="34" charset="0"/>
-            </a:endParaRPr>
-          </a:p>
-          <a:p>
-            <a:pPr algn="just"/>
-            <a:endParaRPr lang="en-US" sz="1200" dirty="0">
-              <a:latin typeface="Arial" panose="020B0604020202020204" pitchFamily="34" charset="0"/>
-              <a:cs typeface="Arial" panose="020B0604020202020204" pitchFamily="34" charset="0"/>
-            </a:endParaRPr>
-          </a:p>
-        </p:txBody>
-      </p:sp>
-      <p:sp>
-        <p:nvSpPr>
-          <p:cNvPr id="11" name="Rectángulo 10">
-            <a:extLst>
-              <a:ext uri="{FF2B5EF4-FFF2-40B4-BE49-F238E27FC236}">
-                <a16:creationId xmlns:a16="http://schemas.microsoft.com/office/drawing/2014/main" id="{B811A5F9-C0B5-716C-70FB-9472E1BC2CD3}"/>
+                <a16:creationId xmlns:a16="http://schemas.microsoft.com/office/drawing/2014/main" id="{11F0F5FC-B571-59FC-7890-3105A6A843BB}"/>
               </a:ext>
             </a:extLst>
           </p:cNvPr>
@@ -7184,8 +7819,8 @@
         </p:nvSpPr>
         <p:spPr>
           <a:xfrm>
-            <a:off x="611030" y="1418373"/>
-            <a:ext cx="2538552" cy="3306028"/>
+            <a:off x="609600" y="1418372"/>
+            <a:ext cx="6324600" cy="4220427"/>
           </a:xfrm>
           <a:prstGeom prst="rect">
             <a:avLst/>
@@ -7224,62 +7859,10 @@
       </p:sp>
       <p:sp>
         <p:nvSpPr>
-          <p:cNvPr id="14" name="Rectángulo 13">
+          <p:cNvPr id="13" name="CuadroTexto 12">
             <a:extLst>
               <a:ext uri="{FF2B5EF4-FFF2-40B4-BE49-F238E27FC236}">
-                <a16:creationId xmlns:a16="http://schemas.microsoft.com/office/drawing/2014/main" id="{6AA857E7-5C39-DCE1-10B5-40300FCF4B26}"/>
-              </a:ext>
-            </a:extLst>
-          </p:cNvPr>
-          <p:cNvSpPr/>
-          <p:nvPr/>
-        </p:nvSpPr>
-        <p:spPr>
-          <a:xfrm>
-            <a:off x="3277315" y="1419036"/>
-            <a:ext cx="2538552" cy="3306028"/>
-          </a:xfrm>
-          <a:prstGeom prst="rect">
-            <a:avLst/>
-          </a:prstGeom>
-          <a:noFill/>
-          <a:ln w="28575">
-            <a:solidFill>
-              <a:srgbClr val="E0700D"/>
-            </a:solidFill>
-          </a:ln>
-        </p:spPr>
-        <p:style>
-          <a:lnRef idx="2">
-            <a:schemeClr val="accent1">
-              <a:shade val="15000"/>
-            </a:schemeClr>
-          </a:lnRef>
-          <a:fillRef idx="1">
-            <a:schemeClr val="accent1"/>
-          </a:fillRef>
-          <a:effectRef idx="0">
-            <a:schemeClr val="accent1"/>
-          </a:effectRef>
-          <a:fontRef idx="minor">
-            <a:schemeClr val="lt1"/>
-          </a:fontRef>
-        </p:style>
-        <p:txBody>
-          <a:bodyPr rtlCol="0" anchor="ctr"/>
-          <a:lstStyle/>
-          <a:p>
-            <a:pPr algn="ctr"/>
-            <a:endParaRPr lang="en-US"/>
-          </a:p>
-        </p:txBody>
-      </p:sp>
-      <p:sp>
-        <p:nvSpPr>
-          <p:cNvPr id="15" name="CuadroTexto 14">
-            <a:extLst>
-              <a:ext uri="{FF2B5EF4-FFF2-40B4-BE49-F238E27FC236}">
-                <a16:creationId xmlns:a16="http://schemas.microsoft.com/office/drawing/2014/main" id="{54CF28B4-1346-F41D-2CD8-EA104ABBFB98}"/>
+                <a16:creationId xmlns:a16="http://schemas.microsoft.com/office/drawing/2014/main" id="{057C499E-829F-FB11-9128-843C937CB822}"/>
               </a:ext>
             </a:extLst>
           </p:cNvPr>
@@ -7288,351 +7871,7 @@
         </p:nvSpPr>
         <p:spPr>
           <a:xfrm>
-            <a:off x="863650" y="2101891"/>
-            <a:ext cx="2033313" cy="1938992"/>
-          </a:xfrm>
-          <a:prstGeom prst="rect">
-            <a:avLst/>
-          </a:prstGeom>
-          <a:noFill/>
-        </p:spPr>
-        <p:txBody>
-          <a:bodyPr wrap="none" rtlCol="0">
-            <a:spAutoFit/>
-          </a:bodyPr>
-          <a:lstStyle/>
-          <a:p>
-            <a:pPr algn="ctr"/>
-            <a:r>
-              <a:rPr lang="es-ES" sz="2000" dirty="0"/>
-              <a:t>Single ring</a:t>
-            </a:r>
-          </a:p>
-          <a:p>
-            <a:pPr algn="ctr"/>
-            <a:r>
-              <a:rPr lang="es-ES" sz="2000" dirty="0"/>
-              <a:t>transfer </a:t>
-            </a:r>
-            <a:r>
-              <a:rPr lang="es-ES" sz="2000" dirty="0" err="1"/>
-              <a:t>functions</a:t>
-            </a:r>
-            <a:endParaRPr lang="es-ES" sz="2000" dirty="0"/>
-          </a:p>
-          <a:p>
-            <a:pPr algn="ctr"/>
-            <a:endParaRPr lang="es-ES" sz="2000" dirty="0"/>
-          </a:p>
-          <a:p>
-            <a:pPr algn="ctr"/>
-            <a:r>
-              <a:rPr lang="es-ES" sz="2000" dirty="0"/>
-              <a:t>Linear </a:t>
-            </a:r>
-            <a:r>
-              <a:rPr lang="es-ES" sz="2000" dirty="0" err="1"/>
-              <a:t>units</a:t>
-            </a:r>
-            <a:endParaRPr lang="es-ES" sz="2000" dirty="0"/>
-          </a:p>
-          <a:p>
-            <a:pPr algn="ctr"/>
-            <a:endParaRPr lang="es-ES" sz="2000" dirty="0"/>
-          </a:p>
-          <a:p>
-            <a:pPr algn="ctr"/>
-            <a:r>
-              <a:rPr lang="es-ES" sz="2000" dirty="0" err="1"/>
-              <a:t>alpha</a:t>
-            </a:r>
-            <a:r>
-              <a:rPr lang="es-ES" sz="2000" dirty="0"/>
-              <a:t>=0 dB/cm</a:t>
-            </a:r>
-            <a:endParaRPr lang="en-US" sz="2000" dirty="0"/>
-          </a:p>
-        </p:txBody>
-      </p:sp>
-      <p:sp>
-        <p:nvSpPr>
-          <p:cNvPr id="9" name="Rectángulo 8">
-            <a:extLst>
-              <a:ext uri="{FF2B5EF4-FFF2-40B4-BE49-F238E27FC236}">
-                <a16:creationId xmlns:a16="http://schemas.microsoft.com/office/drawing/2014/main" id="{11F0F5FC-B571-59FC-7890-3105A6A843BB}"/>
-              </a:ext>
-            </a:extLst>
-          </p:cNvPr>
-          <p:cNvSpPr/>
-          <p:nvPr/>
-        </p:nvSpPr>
-        <p:spPr>
-          <a:xfrm>
-            <a:off x="5943600" y="1418373"/>
-            <a:ext cx="2538552" cy="3306028"/>
-          </a:xfrm>
-          <a:prstGeom prst="rect">
-            <a:avLst/>
-          </a:prstGeom>
-          <a:noFill/>
-          <a:ln w="28575">
-            <a:solidFill>
-              <a:srgbClr val="E0700D"/>
-            </a:solidFill>
-          </a:ln>
-        </p:spPr>
-        <p:style>
-          <a:lnRef idx="2">
-            <a:schemeClr val="accent1">
-              <a:shade val="15000"/>
-            </a:schemeClr>
-          </a:lnRef>
-          <a:fillRef idx="1">
-            <a:schemeClr val="accent1"/>
-          </a:fillRef>
-          <a:effectRef idx="0">
-            <a:schemeClr val="accent1"/>
-          </a:effectRef>
-          <a:fontRef idx="minor">
-            <a:schemeClr val="lt1"/>
-          </a:fontRef>
-        </p:style>
-        <p:txBody>
-          <a:bodyPr rtlCol="0" anchor="ctr"/>
-          <a:lstStyle/>
-          <a:p>
-            <a:pPr algn="ctr"/>
-            <a:endParaRPr lang="en-US"/>
-          </a:p>
-        </p:txBody>
-      </p:sp>
-      <p:sp>
-        <p:nvSpPr>
-          <p:cNvPr id="10" name="CuadroTexto 9">
-            <a:extLst>
-              <a:ext uri="{FF2B5EF4-FFF2-40B4-BE49-F238E27FC236}">
-                <a16:creationId xmlns:a16="http://schemas.microsoft.com/office/drawing/2014/main" id="{3146642F-220B-8F6A-59A8-2D128DDF3BEB}"/>
-              </a:ext>
-            </a:extLst>
-          </p:cNvPr>
-          <p:cNvSpPr txBox="1"/>
-          <p:nvPr/>
-        </p:nvSpPr>
-        <p:spPr>
-          <a:xfrm>
-            <a:off x="3529935" y="2104638"/>
-            <a:ext cx="2033313" cy="1938992"/>
-          </a:xfrm>
-          <a:prstGeom prst="rect">
-            <a:avLst/>
-          </a:prstGeom>
-          <a:noFill/>
-        </p:spPr>
-        <p:txBody>
-          <a:bodyPr wrap="none" rtlCol="0">
-            <a:spAutoFit/>
-          </a:bodyPr>
-          <a:lstStyle/>
-          <a:p>
-            <a:pPr algn="ctr"/>
-            <a:r>
-              <a:rPr lang="es-ES" sz="2000" dirty="0"/>
-              <a:t>Single ring</a:t>
-            </a:r>
-          </a:p>
-          <a:p>
-            <a:pPr algn="ctr"/>
-            <a:r>
-              <a:rPr lang="es-ES" sz="2000" dirty="0"/>
-              <a:t>transfer </a:t>
-            </a:r>
-            <a:r>
-              <a:rPr lang="es-ES" sz="2000" dirty="0" err="1"/>
-              <a:t>functions</a:t>
-            </a:r>
-            <a:endParaRPr lang="es-ES" sz="2000" dirty="0"/>
-          </a:p>
-          <a:p>
-            <a:pPr algn="ctr"/>
-            <a:endParaRPr lang="es-ES" sz="2000" dirty="0"/>
-          </a:p>
-          <a:p>
-            <a:pPr algn="ctr"/>
-            <a:r>
-              <a:rPr lang="es-ES" sz="2000" dirty="0"/>
-              <a:t>Linear </a:t>
-            </a:r>
-            <a:r>
-              <a:rPr lang="es-ES" sz="2000" dirty="0" err="1"/>
-              <a:t>units</a:t>
-            </a:r>
-            <a:endParaRPr lang="es-ES" sz="2000" dirty="0"/>
-          </a:p>
-          <a:p>
-            <a:pPr algn="ctr"/>
-            <a:endParaRPr lang="es-ES" sz="2000" dirty="0"/>
-          </a:p>
-          <a:p>
-            <a:pPr algn="ctr"/>
-            <a:r>
-              <a:rPr lang="es-ES" sz="2000" dirty="0" err="1"/>
-              <a:t>alpha</a:t>
-            </a:r>
-            <a:r>
-              <a:rPr lang="es-ES" sz="2000" dirty="0"/>
-              <a:t>=1 dB/cm</a:t>
-            </a:r>
-            <a:endParaRPr lang="en-US" sz="2000" dirty="0"/>
-          </a:p>
-        </p:txBody>
-      </p:sp>
-      <p:sp>
-        <p:nvSpPr>
-          <p:cNvPr id="13" name="CuadroTexto 12">
-            <a:extLst>
-              <a:ext uri="{FF2B5EF4-FFF2-40B4-BE49-F238E27FC236}">
-                <a16:creationId xmlns:a16="http://schemas.microsoft.com/office/drawing/2014/main" id="{057C499E-829F-FB11-9128-843C937CB822}"/>
-              </a:ext>
-            </a:extLst>
-          </p:cNvPr>
-          <p:cNvSpPr txBox="1"/>
-          <p:nvPr/>
-        </p:nvSpPr>
-        <p:spPr>
-          <a:xfrm>
-            <a:off x="6195187" y="2101891"/>
-            <a:ext cx="2033313" cy="1938992"/>
-          </a:xfrm>
-          <a:prstGeom prst="rect">
-            <a:avLst/>
-          </a:prstGeom>
-          <a:noFill/>
-        </p:spPr>
-        <p:txBody>
-          <a:bodyPr wrap="none" rtlCol="0">
-            <a:spAutoFit/>
-          </a:bodyPr>
-          <a:lstStyle/>
-          <a:p>
-            <a:pPr algn="ctr"/>
-            <a:r>
-              <a:rPr lang="es-ES" sz="2000" dirty="0"/>
-              <a:t>Single ring</a:t>
-            </a:r>
-          </a:p>
-          <a:p>
-            <a:pPr algn="ctr"/>
-            <a:r>
-              <a:rPr lang="es-ES" sz="2000" dirty="0"/>
-              <a:t>transfer </a:t>
-            </a:r>
-            <a:r>
-              <a:rPr lang="es-ES" sz="2000" dirty="0" err="1"/>
-              <a:t>functions</a:t>
-            </a:r>
-            <a:endParaRPr lang="es-ES" sz="2000" dirty="0"/>
-          </a:p>
-          <a:p>
-            <a:pPr algn="ctr"/>
-            <a:endParaRPr lang="es-ES" sz="2000" dirty="0"/>
-          </a:p>
-          <a:p>
-            <a:pPr algn="ctr"/>
-            <a:r>
-              <a:rPr lang="es-ES" sz="2000" dirty="0"/>
-              <a:t>Linear </a:t>
-            </a:r>
-            <a:r>
-              <a:rPr lang="es-ES" sz="2000" dirty="0" err="1"/>
-              <a:t>units</a:t>
-            </a:r>
-            <a:endParaRPr lang="es-ES" sz="2000" dirty="0"/>
-          </a:p>
-          <a:p>
-            <a:pPr algn="ctr"/>
-            <a:endParaRPr lang="es-ES" sz="2000" dirty="0"/>
-          </a:p>
-          <a:p>
-            <a:pPr algn="ctr"/>
-            <a:r>
-              <a:rPr lang="es-ES" sz="2000" dirty="0" err="1"/>
-              <a:t>alpha</a:t>
-            </a:r>
-            <a:r>
-              <a:rPr lang="es-ES" sz="2000" dirty="0"/>
-              <a:t>=2 dB/cm</a:t>
-            </a:r>
-            <a:endParaRPr lang="en-US" sz="2000" dirty="0"/>
-          </a:p>
-        </p:txBody>
-      </p:sp>
-      <p:sp>
-        <p:nvSpPr>
-          <p:cNvPr id="12" name="Rectángulo 11">
-            <a:extLst>
-              <a:ext uri="{FF2B5EF4-FFF2-40B4-BE49-F238E27FC236}">
-                <a16:creationId xmlns:a16="http://schemas.microsoft.com/office/drawing/2014/main" id="{D9D5941A-D9F5-22E7-7E85-0D04C2B214EC}"/>
-              </a:ext>
-            </a:extLst>
-          </p:cNvPr>
-          <p:cNvSpPr/>
-          <p:nvPr/>
-        </p:nvSpPr>
-        <p:spPr>
-          <a:xfrm>
-            <a:off x="8609885" y="1418373"/>
-            <a:ext cx="2538552" cy="3306028"/>
-          </a:xfrm>
-          <a:prstGeom prst="rect">
-            <a:avLst/>
-          </a:prstGeom>
-          <a:noFill/>
-          <a:ln w="28575">
-            <a:solidFill>
-              <a:srgbClr val="E0700D"/>
-            </a:solidFill>
-          </a:ln>
-        </p:spPr>
-        <p:style>
-          <a:lnRef idx="2">
-            <a:schemeClr val="accent1">
-              <a:shade val="15000"/>
-            </a:schemeClr>
-          </a:lnRef>
-          <a:fillRef idx="1">
-            <a:schemeClr val="accent1"/>
-          </a:fillRef>
-          <a:effectRef idx="0">
-            <a:schemeClr val="accent1"/>
-          </a:effectRef>
-          <a:fontRef idx="minor">
-            <a:schemeClr val="lt1"/>
-          </a:fontRef>
-        </p:style>
-        <p:txBody>
-          <a:bodyPr rtlCol="0" anchor="ctr"/>
-          <a:lstStyle/>
-          <a:p>
-            <a:pPr algn="ctr"/>
-            <a:endParaRPr lang="en-US"/>
-          </a:p>
-        </p:txBody>
-      </p:sp>
-      <p:sp>
-        <p:nvSpPr>
-          <p:cNvPr id="16" name="CuadroTexto 15">
-            <a:extLst>
-              <a:ext uri="{FF2B5EF4-FFF2-40B4-BE49-F238E27FC236}">
-                <a16:creationId xmlns:a16="http://schemas.microsoft.com/office/drawing/2014/main" id="{4A6C8490-F65B-32C9-44E8-9A1A1A1B1769}"/>
-              </a:ext>
-            </a:extLst>
-          </p:cNvPr>
-          <p:cNvSpPr txBox="1"/>
-          <p:nvPr/>
-        </p:nvSpPr>
-        <p:spPr>
-          <a:xfrm>
-            <a:off x="8861472" y="2101891"/>
+            <a:off x="2133600" y="1908762"/>
             <a:ext cx="2033313" cy="1938992"/>
           </a:xfrm>
           <a:prstGeom prst="rect">
@@ -7716,7 +7955,7 @@
           <a:blip>
             <a:extLst>
               <a:ext uri="{96DAC541-7B7A-43D3-8B79-37D633B846F1}">
-                <asvg:svgBlip xmlns:asvg="http://schemas.microsoft.com/office/drawing/2016/SVG/main" r:embed="rId2"/>
+                <asvg:svgBlip xmlns:asvg="http://schemas.microsoft.com/office/drawing/2016/SVG/main" r:embed="rId3"/>
               </a:ext>
             </a:extLst>
           </a:blip>
@@ -7822,6 +8061,36 @@
           </a:p>
         </p:txBody>
       </p:sp>
+      <p:pic>
+        <p:nvPicPr>
+          <p:cNvPr id="3" name="Imagen 2">
+            <a:extLst>
+              <a:ext uri="{FF2B5EF4-FFF2-40B4-BE49-F238E27FC236}">
+                <a16:creationId xmlns:a16="http://schemas.microsoft.com/office/drawing/2014/main" id="{36F556D2-C386-3CC4-590A-7B6584497FCA}"/>
+              </a:ext>
+            </a:extLst>
+          </p:cNvPr>
+          <p:cNvPicPr>
+            <a:picLocks noChangeAspect="1"/>
+          </p:cNvPicPr>
+          <p:nvPr/>
+        </p:nvPicPr>
+        <p:blipFill>
+          <a:blip r:embed="rId4"/>
+          <a:stretch>
+            <a:fillRect/>
+          </a:stretch>
+        </p:blipFill>
+        <p:spPr>
+          <a:xfrm>
+            <a:off x="696686" y="1801377"/>
+            <a:ext cx="6156649" cy="3454415"/>
+          </a:xfrm>
+          <a:prstGeom prst="rect">
+            <a:avLst/>
+          </a:prstGeom>
+        </p:spPr>
+      </p:pic>
     </p:spTree>
     <p:extLst>
       <p:ext uri="{BB962C8B-B14F-4D97-AF65-F5344CB8AC3E}">
@@ -9464,8 +9733,8 @@
           </a:p>
         </p:txBody>
       </p:sp>
-      <mc:AlternateContent xmlns:mc="http://schemas.openxmlformats.org/markup-compatibility/2006">
-        <mc:Choice xmlns:a14="http://schemas.microsoft.com/office/drawing/2010/main" Requires="a14">
+      <mc:AlternateContent xmlns:mc="http://schemas.openxmlformats.org/markup-compatibility/2006" xmlns:a14="http://schemas.microsoft.com/office/drawing/2010/main">
+        <mc:Choice Requires="a14">
           <p:sp>
             <p:nvSpPr>
               <p:cNvPr id="2" name="CuadroTexto 1">
@@ -9587,15 +9856,21 @@
                 <a14:m>
                   <m:oMath xmlns:m="http://schemas.openxmlformats.org/officeDocument/2006/math">
                     <m:r>
-                      <a:rPr lang="es-ES" sz="1200" i="1"/>
+                      <a:rPr lang="es-ES" sz="1200" i="1">
+                        <a:latin typeface="Cambria Math" panose="02040503050406030204" pitchFamily="18" charset="0"/>
+                      </a:rPr>
                       <m:t>𝑑𝐿</m:t>
                     </m:r>
                     <m:r>
-                      <a:rPr lang="es-ES" sz="1200"/>
+                      <a:rPr lang="es-ES" sz="1200">
+                        <a:latin typeface="Cambria Math" panose="02040503050406030204" pitchFamily="18" charset="0"/>
+                      </a:rPr>
                       <m:t>=</m:t>
                     </m:r>
                     <m:r>
-                      <a:rPr lang="es-ES" sz="1200"/>
+                      <a:rPr lang="es-ES" sz="1200">
+                        <a:latin typeface="Cambria Math" panose="02040503050406030204" pitchFamily="18" charset="0"/>
+                      </a:rPr>
                       <m:t>0</m:t>
                     </m:r>
                   </m:oMath>
@@ -9627,38 +9902,52 @@
                 <a14:m>
                   <m:oMath xmlns:m="http://schemas.openxmlformats.org/officeDocument/2006/math">
                     <m:r>
-                      <a:rPr lang="es-ES" sz="1200"/>
+                      <a:rPr lang="es-ES" sz="1200">
+                        <a:latin typeface="Cambria Math" panose="02040503050406030204" pitchFamily="18" charset="0"/>
+                      </a:rPr>
                       <m:t>∣</m:t>
                     </m:r>
                     <m:r>
-                      <a:rPr lang="es-ES" sz="1200" i="1"/>
+                      <a:rPr lang="es-ES" sz="1200" i="1">
+                        <a:latin typeface="Cambria Math" panose="02040503050406030204" pitchFamily="18" charset="0"/>
+                      </a:rPr>
                       <m:t>𝐻</m:t>
                     </m:r>
                     <m:sSup>
                       <m:sSupPr>
                         <m:ctrlPr>
-                          <a:rPr lang="ar-AE" sz="1200" i="1"/>
+                          <a:rPr lang="ar-AE" sz="1200" i="1">
+                            <a:latin typeface="Cambria Math" panose="02040503050406030204" pitchFamily="18" charset="0"/>
+                          </a:rPr>
                         </m:ctrlPr>
                       </m:sSupPr>
                       <m:e>
                         <m:r>
-                          <a:rPr lang="ar-AE" sz="1200"/>
+                          <a:rPr lang="ar-AE" sz="1200">
+                            <a:latin typeface="Cambria Math" panose="02040503050406030204" pitchFamily="18" charset="0"/>
+                          </a:rPr>
                           <m:t>∣</m:t>
                         </m:r>
                       </m:e>
                       <m:sup>
                         <m:r>
-                          <a:rPr lang="ar-AE" sz="1200"/>
+                          <a:rPr lang="ar-AE" sz="1200">
+                            <a:latin typeface="Cambria Math" panose="02040503050406030204" pitchFamily="18" charset="0"/>
+                          </a:rPr>
                           <m:t>2</m:t>
                         </m:r>
                       </m:sup>
                     </m:sSup>
                     <m:r>
-                      <a:rPr lang="ar-AE" sz="1200"/>
+                      <a:rPr lang="ar-AE" sz="1200">
+                        <a:latin typeface="Cambria Math" panose="02040503050406030204" pitchFamily="18" charset="0"/>
+                      </a:rPr>
                       <m:t>=</m:t>
                     </m:r>
                     <m:r>
-                      <a:rPr lang="ar-AE" sz="1200"/>
+                      <a:rPr lang="ar-AE" sz="1200">
+                        <a:latin typeface="Cambria Math" panose="02040503050406030204" pitchFamily="18" charset="0"/>
+                      </a:rPr>
                       <m:t>1</m:t>
                     </m:r>
                   </m:oMath>
@@ -9692,7 +9981,7 @@
             </p:txBody>
           </p:sp>
         </mc:Choice>
-        <mc:Fallback>
+        <mc:Fallback xmlns="">
           <p:sp>
             <p:nvSpPr>
               <p:cNvPr id="2" name="CuadroTexto 1">
@@ -10618,8 +10907,8 @@
           </a:p>
         </p:txBody>
       </p:sp>
-      <mc:AlternateContent xmlns:mc="http://schemas.openxmlformats.org/markup-compatibility/2006">
-        <mc:Choice xmlns:a14="http://schemas.microsoft.com/office/drawing/2010/main" Requires="a14">
+      <mc:AlternateContent xmlns:mc="http://schemas.openxmlformats.org/markup-compatibility/2006" xmlns:a14="http://schemas.microsoft.com/office/drawing/2010/main">
+        <mc:Choice Requires="a14">
           <p:sp>
             <p:nvSpPr>
               <p:cNvPr id="2" name="CuadroTexto 1">
@@ -10692,15 +10981,21 @@
                 <a14:m>
                   <m:oMath xmlns:m="http://schemas.openxmlformats.org/officeDocument/2006/math">
                     <m:r>
-                      <a:rPr lang="es-ES" sz="1200" i="1"/>
+                      <a:rPr lang="es-ES" sz="1200" i="1">
+                        <a:latin typeface="Cambria Math" panose="02040503050406030204" pitchFamily="18" charset="0"/>
+                      </a:rPr>
                       <m:t>𝑑𝐿</m:t>
                     </m:r>
                     <m:r>
-                      <a:rPr lang="es-ES" sz="1200"/>
+                      <a:rPr lang="es-ES" sz="1200">
+                        <a:latin typeface="Cambria Math" panose="02040503050406030204" pitchFamily="18" charset="0"/>
+                      </a:rPr>
                       <m:t>=</m:t>
                     </m:r>
                     <m:r>
-                      <a:rPr lang="es-ES" sz="1200"/>
+                      <a:rPr lang="es-ES" sz="1200">
+                        <a:latin typeface="Cambria Math" panose="02040503050406030204" pitchFamily="18" charset="0"/>
+                      </a:rPr>
                       <m:t>100</m:t>
                     </m:r>
                     <m:r>
@@ -10714,11 +11009,15 @@
                       <m:t> </m:t>
                     </m:r>
                     <m:r>
-                      <a:rPr lang="es-ES" sz="1200" i="1"/>
+                      <a:rPr lang="es-ES" sz="1200" i="1">
+                        <a:latin typeface="Cambria Math" panose="02040503050406030204" pitchFamily="18" charset="0"/>
+                      </a:rPr>
                       <m:t>𝜇</m:t>
                     </m:r>
                     <m:r>
-                      <a:rPr lang="es-ES" sz="1200" i="1"/>
+                      <a:rPr lang="es-ES" sz="1200" i="1">
+                        <a:latin typeface="Cambria Math" panose="02040503050406030204" pitchFamily="18" charset="0"/>
+                      </a:rPr>
                       <m:t>𝑚</m:t>
                     </m:r>
                   </m:oMath>
@@ -10819,7 +11118,9 @@
                 <a14:m>
                   <m:oMath xmlns:m="http://schemas.openxmlformats.org/officeDocument/2006/math">
                     <m:r>
-                      <a:rPr lang="es-ES" sz="1200" i="1"/>
+                      <a:rPr lang="es-ES" sz="1200" i="1">
+                        <a:latin typeface="Cambria Math" panose="02040503050406030204" pitchFamily="18" charset="0"/>
+                      </a:rPr>
                       <m:t>𝑑𝐿</m:t>
                     </m:r>
                   </m:oMath>
@@ -10842,7 +11143,7 @@
             </p:txBody>
           </p:sp>
         </mc:Choice>
-        <mc:Fallback>
+        <mc:Fallback xmlns="">
           <p:sp>
             <p:nvSpPr>
               <p:cNvPr id="2" name="CuadroTexto 1">

</xml_diff>